<commit_message>
Add unit-cost one-pager, statistical benchmarking memo, public dataset and appendix slides
- Regulatory one-pager: seven cost boundaries with $/kW, $/kWh and what each adds
- Statistical benchmarking memo: reference class (13 utility-owned projects
  <= 100 MWh), log-log regression on 26 public projects (size and duration
  elasticities, 80% prediction interval), Monte Carlo on the thirteen cost
  layers (base and Class 5-like calibrations), estimate-to-actual uplift on
  comparables, ISO interconnection references, AACE and Flyvbjerg citations
- Workbook: Public Projects and Statistics tabs (578 formulas, zero errors)
- Deck: three appendix slides (reference class, regression, Monte Carlo)
- build/data: 44-project public cost dataset with sourcing notes; ISO/FERC/
  state-PUC reference log; model scripts and results

Co-Authored-By: Claude Fable 5.1 <noreply@anthropic.com>
Claude-Session: https://claude.ai/code/session_01YAU7MDk5K6GEm6c4td5TUq
</commit_message>
<xml_diff>
--- a/Hyde Park BESS/6) Cost Analysis Deliverables/Hyde Park BESS - Cost Analysis Deck.pptx
+++ b/Hyde Park BESS/6) Cost Analysis Deliverables/Hyde Park BESS - Cost Analysis Deck.pptx
@@ -20,6 +20,9 @@
     <p:sldId id="268" r:id="rId20"/>
     <p:sldId id="269" r:id="rId21"/>
     <p:sldId id="270" r:id="rId22"/>
+    <p:sldId id="272" r:id="rId24"/>
+    <p:sldId id="273" r:id="rId25"/>
+    <p:sldId id="274" r:id="rId26"/>
     <p:sldId id="271" r:id="rId23"/>
   </p:sldIdLst>
   <p:sldSz cx="12191695" cy="6858000" type="screen4x3"/>
@@ -12191,6 +12194,2092 @@
                 <a:latin typeface="Calibri"/>
               </a:rPr>
               <a:t>EstimatingCoE | Eversource Energy | Stewards of Affordability</a:t>
+            </a:r>
+          </a:p>
+        </p:txBody>
+      </p:sp>
+    </p:spTree>
+  </p:cSld>
+  <p:clrMapOvr>
+    <a:masterClrMapping/>
+  </p:clrMapOvr>
+</p:sld>
+</file>
+
+<file path=ppt/slides/slide17.xml><?xml version="1.0" encoding="utf-8"?>
+<p:sld xmlns:a="http://schemas.openxmlformats.org/drawingml/2006/main" xmlns:p="http://schemas.openxmlformats.org/presentationml/2006/main" xmlns:r="http://schemas.openxmlformats.org/officeDocument/2006/relationships">
+  <p:cSld>
+    <p:spTree>
+      <p:nvGrpSpPr>
+        <p:cNvPr id="1" name=""/>
+        <p:cNvGrpSpPr/>
+        <p:nvPr/>
+      </p:nvGrpSpPr>
+      <p:grpSpPr/>
+      <p:sp>
+        <p:nvSpPr>
+          <p:cNvPr id="2" name="Rectangle 1"/>
+          <p:cNvSpPr/>
+          <p:nvPr/>
+        </p:nvSpPr>
+        <p:spPr>
+          <a:xfrm>
+            <a:off x="0" y="0"/>
+            <a:ext cx="12191695" cy="6858000"/>
+          </a:xfrm>
+          <a:prstGeom prst="rect">
+            <a:avLst/>
+          </a:prstGeom>
+          <a:solidFill>
+            <a:srgbClr val="FFFFFF"/>
+          </a:solidFill>
+          <a:ln>
+            <a:noFill/>
+          </a:ln>
+          <a:effectLst/>
+        </p:spPr>
+        <p:style>
+          <a:lnRef idx="1">
+            <a:schemeClr val="accent1"/>
+          </a:lnRef>
+          <a:fillRef idx="3">
+            <a:schemeClr val="accent1"/>
+          </a:fillRef>
+          <a:effectRef idx="2">
+            <a:schemeClr val="accent1"/>
+          </a:effectRef>
+          <a:fontRef idx="minor">
+            <a:schemeClr val="lt1"/>
+          </a:fontRef>
+        </p:style>
+        <p:txBody>
+          <a:bodyPr rtlCol="0" anchor="ctr"/>
+          <a:lstStyle/>
+          <a:p>
+            <a:pPr algn="ctr"/>
+          </a:p>
+        </p:txBody>
+      </p:sp>
+      <p:sp>
+        <p:nvSpPr>
+          <p:cNvPr id="3" name="TextBox 2"/>
+          <p:cNvSpPr txBox="1"/>
+          <p:nvPr/>
+        </p:nvSpPr>
+        <p:spPr>
+          <a:xfrm>
+            <a:off x="548640" y="256032"/>
+            <a:ext cx="10058400" cy="274320"/>
+          </a:xfrm>
+          <a:prstGeom prst="rect">
+            <a:avLst/>
+          </a:prstGeom>
+          <a:noFill/>
+        </p:spPr>
+        <p:txBody>
+          <a:bodyPr wrap="square" lIns="45720" rIns="45720" tIns="27432" bIns="27432" anchor="t">
+            <a:spAutoFit/>
+          </a:bodyPr>
+          <a:lstStyle/>
+          <a:p>
+            <a:pPr algn="l">
+              <a:lnSpc>
+                <a:spcPct val="105000"/>
+              </a:lnSpc>
+              <a:spcAft>
+                <a:spcPts val="400"/>
+              </a:spcAft>
+            </a:pPr>
+            <a:r>
+              <a:rPr sz="1100" b="1" i="0">
+                <a:solidFill>
+                  <a:srgbClr val="6E1F2E"/>
+                </a:solidFill>
+                <a:latin typeface="Calibri"/>
+              </a:rPr>
+              <a:t>APPENDIX A. REFERENCE CLASS (PUBLIC DISCLOSURES, NOMINAL $/KWH)</a:t>
+            </a:r>
+          </a:p>
+        </p:txBody>
+      </p:sp>
+      <p:sp>
+        <p:nvSpPr>
+          <p:cNvPr id="4" name="TextBox 3"/>
+          <p:cNvSpPr txBox="1"/>
+          <p:nvPr/>
+        </p:nvSpPr>
+        <p:spPr>
+          <a:xfrm>
+            <a:off x="548640" y="475488"/>
+            <a:ext cx="11064240" cy="868680"/>
+          </a:xfrm>
+          <a:prstGeom prst="rect">
+            <a:avLst/>
+          </a:prstGeom>
+          <a:noFill/>
+        </p:spPr>
+        <p:txBody>
+          <a:bodyPr wrap="square" lIns="45720" rIns="45720" tIns="27432" bIns="27432" anchor="t">
+            <a:spAutoFit/>
+          </a:bodyPr>
+          <a:lstStyle/>
+          <a:p>
+            <a:pPr algn="l">
+              <a:lnSpc>
+                <a:spcPct val="100000"/>
+              </a:lnSpc>
+              <a:spcAft>
+                <a:spcPts val="400"/>
+              </a:spcAft>
+            </a:pPr>
+            <a:r>
+              <a:rPr sz="2300" b="1" i="0">
+                <a:solidFill>
+                  <a:srgbClr val="001E60"/>
+                </a:solidFill>
+                <a:latin typeface="Georgia"/>
+              </a:rPr>
+              <a:t>Thirteen utility-owned projects at or below 100 MWh: where Hyde Park sits</a:t>
+            </a:r>
+          </a:p>
+        </p:txBody>
+      </p:sp>
+      <p:sp>
+        <p:nvSpPr>
+          <p:cNvPr id="5" name="TextBox 4"/>
+          <p:cNvSpPr txBox="1"/>
+          <p:nvPr/>
+        </p:nvSpPr>
+        <p:spPr>
+          <a:xfrm>
+            <a:off x="548640" y="6419088"/>
+            <a:ext cx="8229600" cy="274320"/>
+          </a:xfrm>
+          <a:prstGeom prst="rect">
+            <a:avLst/>
+          </a:prstGeom>
+          <a:noFill/>
+        </p:spPr>
+        <p:txBody>
+          <a:bodyPr wrap="square" lIns="45720" rIns="45720" tIns="27432" bIns="27432" anchor="t">
+            <a:spAutoFit/>
+          </a:bodyPr>
+          <a:lstStyle/>
+          <a:p>
+            <a:pPr algn="l">
+              <a:lnSpc>
+                <a:spcPct val="105000"/>
+              </a:lnSpc>
+              <a:spcAft>
+                <a:spcPts val="400"/>
+              </a:spcAft>
+            </a:pPr>
+            <a:r>
+              <a:rPr sz="1000" b="0" i="0">
+                <a:solidFill>
+                  <a:srgbClr val="6B7280"/>
+                </a:solidFill>
+                <a:latin typeface="Calibri"/>
+              </a:rPr>
+              <a:t>EstimatingCoE | Eversource Energy | Stewards of Affordability</a:t>
+            </a:r>
+          </a:p>
+        </p:txBody>
+      </p:sp>
+      <p:sp>
+        <p:nvSpPr>
+          <p:cNvPr id="6" name="TextBox 5"/>
+          <p:cNvSpPr txBox="1"/>
+          <p:nvPr/>
+        </p:nvSpPr>
+        <p:spPr>
+          <a:xfrm>
+            <a:off x="10972800" y="6419088"/>
+            <a:ext cx="685800" cy="274320"/>
+          </a:xfrm>
+          <a:prstGeom prst="rect">
+            <a:avLst/>
+          </a:prstGeom>
+          <a:noFill/>
+        </p:spPr>
+        <p:txBody>
+          <a:bodyPr wrap="square" lIns="45720" rIns="45720" tIns="27432" bIns="27432" anchor="t">
+            <a:spAutoFit/>
+          </a:bodyPr>
+          <a:lstStyle/>
+          <a:p>
+            <a:pPr algn="r">
+              <a:lnSpc>
+                <a:spcPct val="105000"/>
+              </a:lnSpc>
+              <a:spcAft>
+                <a:spcPts val="400"/>
+              </a:spcAft>
+            </a:pPr>
+            <a:r>
+              <a:rPr sz="1000" b="0" i="0">
+                <a:solidFill>
+                  <a:srgbClr val="6B7280"/>
+                </a:solidFill>
+                <a:latin typeface="Calibri"/>
+              </a:rPr>
+              <a:t>16</a:t>
+            </a:r>
+          </a:p>
+        </p:txBody>
+      </p:sp>
+      <p:pic>
+        <p:nvPicPr>
+          <p:cNvPr id="7" name="Picture 6" descr="stats_refclass.png"/>
+          <p:cNvPicPr>
+            <a:picLocks noChangeAspect="1"/>
+          </p:cNvPicPr>
+          <p:nvPr/>
+        </p:nvPicPr>
+        <p:blipFill>
+          <a:blip r:embed="rId2"/>
+          <a:stretch>
+            <a:fillRect/>
+          </a:stretch>
+        </p:blipFill>
+        <p:spPr>
+          <a:xfrm>
+            <a:off x="457200" y="1417320"/>
+            <a:ext cx="7223760" cy="2471286"/>
+          </a:xfrm>
+          <a:prstGeom prst="rect">
+            <a:avLst/>
+          </a:prstGeom>
+        </p:spPr>
+      </p:pic>
+      <p:sp>
+        <p:nvSpPr>
+          <p:cNvPr id="8" name="TextBox 7"/>
+          <p:cNvSpPr txBox="1"/>
+          <p:nvPr/>
+        </p:nvSpPr>
+        <p:spPr>
+          <a:xfrm>
+            <a:off x="7863840" y="1417320"/>
+            <a:ext cx="3840480" cy="4846320"/>
+          </a:xfrm>
+          <a:prstGeom prst="rect">
+            <a:avLst/>
+          </a:prstGeom>
+          <a:noFill/>
+        </p:spPr>
+        <p:txBody>
+          <a:bodyPr wrap="square" lIns="45720">
+            <a:spAutoFit/>
+          </a:bodyPr>
+          <a:lstStyle/>
+          <a:p>
+            <a:pPr>
+              <a:lnSpc>
+                <a:spcPct val="105000"/>
+              </a:lnSpc>
+              <a:spcAft>
+                <a:spcPts val="600"/>
+              </a:spcAft>
+            </a:pPr>
+            <a:r>
+              <a:rPr sz="1250">
+                <a:solidFill>
+                  <a:srgbClr val="FFC72C"/>
+                </a:solidFill>
+                <a:latin typeface="Calibri"/>
+              </a:rPr>
+              <a:t>▪  </a:t>
+            </a:r>
+            <a:r>
+              <a:rPr b="1" sz="1250">
+                <a:solidFill>
+                  <a:srgbClr val="1F2A44"/>
+                </a:solidFill>
+                <a:latin typeface="Calibri"/>
+              </a:rPr>
+              <a:t>Median </a:t>
+            </a:r>
+            <a:r>
+              <a:rPr sz="1250">
+                <a:solidFill>
+                  <a:srgbClr val="1F2A44"/>
+                </a:solidFill>
+                <a:latin typeface="Calibri"/>
+              </a:rPr>
+              <a:t>$1,235/kWh; interquartile $750 to $1,289.</a:t>
+            </a:r>
+          </a:p>
+          <a:p>
+            <a:pPr>
+              <a:lnSpc>
+                <a:spcPct val="105000"/>
+              </a:lnSpc>
+              <a:spcAft>
+                <a:spcPts val="600"/>
+              </a:spcAft>
+            </a:pPr>
+            <a:r>
+              <a:rPr sz="1250">
+                <a:solidFill>
+                  <a:srgbClr val="FFC72C"/>
+                </a:solidFill>
+                <a:latin typeface="Calibri"/>
+              </a:rPr>
+              <a:t>▪  </a:t>
+            </a:r>
+            <a:r>
+              <a:rPr b="1" sz="1250">
+                <a:solidFill>
+                  <a:srgbClr val="1F2A44"/>
+                </a:solidFill>
+                <a:latin typeface="Calibri"/>
+              </a:rPr>
+              <a:t>Hyde Park battery installed, $833: </a:t>
+            </a:r>
+            <a:r>
+              <a:rPr sz="1250">
+                <a:solidFill>
+                  <a:srgbClr val="1F2A44"/>
+                </a:solidFill>
+                <a:latin typeface="Calibri"/>
+              </a:rPr>
+              <a:t>38% percentile.</a:t>
+            </a:r>
+          </a:p>
+          <a:p>
+            <a:pPr>
+              <a:lnSpc>
+                <a:spcPct val="105000"/>
+              </a:lnSpc>
+              <a:spcAft>
+                <a:spcPts val="600"/>
+              </a:spcAft>
+            </a:pPr>
+            <a:r>
+              <a:rPr sz="1250">
+                <a:solidFill>
+                  <a:srgbClr val="FFC72C"/>
+                </a:solidFill>
+                <a:latin typeface="Calibri"/>
+              </a:rPr>
+              <a:t>▪  </a:t>
+            </a:r>
+            <a:r>
+              <a:rPr b="1" sz="1250">
+                <a:solidFill>
+                  <a:srgbClr val="1F2A44"/>
+                </a:solidFill>
+                <a:latin typeface="Calibri"/>
+              </a:rPr>
+              <a:t>Station complete, direct, $1,483: </a:t>
+            </a:r>
+            <a:r>
+              <a:rPr sz="1250">
+                <a:solidFill>
+                  <a:srgbClr val="1F2A44"/>
+                </a:solidFill>
+                <a:latin typeface="Calibri"/>
+              </a:rPr>
+              <a:t>77% percentile, beside Fairhaven ($1,659 actual, 2023), Chateaugay ($1,490, 2023) and Provincetown ($1,289, 2022).</a:t>
+            </a:r>
+          </a:p>
+          <a:p>
+            <a:pPr>
+              <a:lnSpc>
+                <a:spcPct val="105000"/>
+              </a:lnSpc>
+              <a:spcAft>
+                <a:spcPts val="600"/>
+              </a:spcAft>
+            </a:pPr>
+            <a:r>
+              <a:rPr sz="1250">
+                <a:solidFill>
+                  <a:srgbClr val="FFC72C"/>
+                </a:solidFill>
+                <a:latin typeface="Calibri"/>
+              </a:rPr>
+              <a:t>▪  </a:t>
+            </a:r>
+            <a:r>
+              <a:rPr b="1" sz="1250">
+                <a:solidFill>
+                  <a:srgbClr val="1F2A44"/>
+                </a:solidFill>
+                <a:latin typeface="Calibri"/>
+              </a:rPr>
+              <a:t>Approval level, $2,862: </a:t>
+            </a:r>
+            <a:r>
+              <a:rPr sz="1250">
+                <a:solidFill>
+                  <a:srgbClr val="1F2A44"/>
+                </a:solidFill>
+                <a:latin typeface="Calibri"/>
+              </a:rPr>
+              <a:t>above every member. The loaders ($23.7M) and the two interconnection scopes are what the comparables do not carry.</a:t>
+            </a:r>
+          </a:p>
+          <a:p>
+            <a:pPr>
+              <a:lnSpc>
+                <a:spcPct val="105000"/>
+              </a:lnSpc>
+              <a:spcAft>
+                <a:spcPts val="600"/>
+              </a:spcAft>
+            </a:pPr>
+            <a:r>
+              <a:rPr sz="1250">
+                <a:solidFill>
+                  <a:srgbClr val="FFC72C"/>
+                </a:solidFill>
+                <a:latin typeface="Calibri"/>
+              </a:rPr>
+              <a:t>▪  </a:t>
+            </a:r>
+            <a:r>
+              <a:rPr b="1" sz="1250">
+                <a:solidFill>
+                  <a:srgbClr val="1F2A44"/>
+                </a:solidFill>
+                <a:latin typeface="Calibri"/>
+              </a:rPr>
+              <a:t>Caveat: </a:t>
+            </a:r>
+            <a:r>
+              <a:rPr sz="1250">
+                <a:solidFill>
+                  <a:srgbClr val="1F2A44"/>
+                </a:solidFill>
+                <a:latin typeface="Calibri"/>
+              </a:rPr>
+              <a:t>figures retrieved from search excerpts of regulator and utility documents; verify at source before external use.</a:t>
+            </a:r>
+          </a:p>
+        </p:txBody>
+      </p:sp>
+    </p:spTree>
+  </p:cSld>
+  <p:clrMapOvr>
+    <a:masterClrMapping/>
+  </p:clrMapOvr>
+</p:sld>
+</file>
+
+<file path=ppt/slides/slide18.xml><?xml version="1.0" encoding="utf-8"?>
+<p:sld xmlns:a="http://schemas.openxmlformats.org/drawingml/2006/main" xmlns:p="http://schemas.openxmlformats.org/presentationml/2006/main" xmlns:r="http://schemas.openxmlformats.org/officeDocument/2006/relationships">
+  <p:cSld>
+    <p:spTree>
+      <p:nvGrpSpPr>
+        <p:cNvPr id="1" name=""/>
+        <p:cNvGrpSpPr/>
+        <p:nvPr/>
+      </p:nvGrpSpPr>
+      <p:grpSpPr/>
+      <p:sp>
+        <p:nvSpPr>
+          <p:cNvPr id="2" name="Rectangle 1"/>
+          <p:cNvSpPr/>
+          <p:nvPr/>
+        </p:nvSpPr>
+        <p:spPr>
+          <a:xfrm>
+            <a:off x="0" y="0"/>
+            <a:ext cx="12191695" cy="6858000"/>
+          </a:xfrm>
+          <a:prstGeom prst="rect">
+            <a:avLst/>
+          </a:prstGeom>
+          <a:solidFill>
+            <a:srgbClr val="FFFFFF"/>
+          </a:solidFill>
+          <a:ln>
+            <a:noFill/>
+          </a:ln>
+          <a:effectLst/>
+        </p:spPr>
+        <p:style>
+          <a:lnRef idx="1">
+            <a:schemeClr val="accent1"/>
+          </a:lnRef>
+          <a:fillRef idx="3">
+            <a:schemeClr val="accent1"/>
+          </a:fillRef>
+          <a:effectRef idx="2">
+            <a:schemeClr val="accent1"/>
+          </a:effectRef>
+          <a:fontRef idx="minor">
+            <a:schemeClr val="lt1"/>
+          </a:fontRef>
+        </p:style>
+        <p:txBody>
+          <a:bodyPr rtlCol="0" anchor="ctr"/>
+          <a:lstStyle/>
+          <a:p>
+            <a:pPr algn="ctr"/>
+          </a:p>
+        </p:txBody>
+      </p:sp>
+      <p:sp>
+        <p:nvSpPr>
+          <p:cNvPr id="3" name="TextBox 2"/>
+          <p:cNvSpPr txBox="1"/>
+          <p:nvPr/>
+        </p:nvSpPr>
+        <p:spPr>
+          <a:xfrm>
+            <a:off x="548640" y="256032"/>
+            <a:ext cx="10058400" cy="274320"/>
+          </a:xfrm>
+          <a:prstGeom prst="rect">
+            <a:avLst/>
+          </a:prstGeom>
+          <a:noFill/>
+        </p:spPr>
+        <p:txBody>
+          <a:bodyPr wrap="square" lIns="45720" rIns="45720" tIns="27432" bIns="27432" anchor="t">
+            <a:spAutoFit/>
+          </a:bodyPr>
+          <a:lstStyle/>
+          <a:p>
+            <a:pPr algn="l">
+              <a:lnSpc>
+                <a:spcPct val="105000"/>
+              </a:lnSpc>
+              <a:spcAft>
+                <a:spcPts val="400"/>
+              </a:spcAft>
+            </a:pPr>
+            <a:r>
+              <a:rPr sz="1100" b="1" i="0">
+                <a:solidFill>
+                  <a:srgbClr val="6E1F2E"/>
+                </a:solidFill>
+                <a:latin typeface="Calibri"/>
+              </a:rPr>
+              <a:t>APPENDIX B. REGRESSION ON 26 PUBLIC PROJECTS</a:t>
+            </a:r>
+          </a:p>
+        </p:txBody>
+      </p:sp>
+      <p:sp>
+        <p:nvSpPr>
+          <p:cNvPr id="4" name="TextBox 3"/>
+          <p:cNvSpPr txBox="1"/>
+          <p:nvPr/>
+        </p:nvSpPr>
+        <p:spPr>
+          <a:xfrm>
+            <a:off x="548640" y="475488"/>
+            <a:ext cx="11064240" cy="868680"/>
+          </a:xfrm>
+          <a:prstGeom prst="rect">
+            <a:avLst/>
+          </a:prstGeom>
+          <a:noFill/>
+        </p:spPr>
+        <p:txBody>
+          <a:bodyPr wrap="square" lIns="45720" rIns="45720" tIns="27432" bIns="27432" anchor="t">
+            <a:spAutoFit/>
+          </a:bodyPr>
+          <a:lstStyle/>
+          <a:p>
+            <a:pPr algn="l">
+              <a:lnSpc>
+                <a:spcPct val="100000"/>
+              </a:lnSpc>
+              <a:spcAft>
+                <a:spcPts val="400"/>
+              </a:spcAft>
+            </a:pPr>
+            <a:r>
+              <a:rPr sz="2300" b="1" i="0">
+                <a:solidFill>
+                  <a:srgbClr val="001E60"/>
+                </a:solidFill>
+                <a:latin typeface="Georgia"/>
+              </a:rPr>
+              <a:t>Size and duration explain two thirds of the spread in public costs; Hyde Park's direct cost is high-normal</a:t>
+            </a:r>
+          </a:p>
+        </p:txBody>
+      </p:sp>
+      <p:sp>
+        <p:nvSpPr>
+          <p:cNvPr id="5" name="TextBox 4"/>
+          <p:cNvSpPr txBox="1"/>
+          <p:nvPr/>
+        </p:nvSpPr>
+        <p:spPr>
+          <a:xfrm>
+            <a:off x="548640" y="6419088"/>
+            <a:ext cx="8229600" cy="274320"/>
+          </a:xfrm>
+          <a:prstGeom prst="rect">
+            <a:avLst/>
+          </a:prstGeom>
+          <a:noFill/>
+        </p:spPr>
+        <p:txBody>
+          <a:bodyPr wrap="square" lIns="45720" rIns="45720" tIns="27432" bIns="27432" anchor="t">
+            <a:spAutoFit/>
+          </a:bodyPr>
+          <a:lstStyle/>
+          <a:p>
+            <a:pPr algn="l">
+              <a:lnSpc>
+                <a:spcPct val="105000"/>
+              </a:lnSpc>
+              <a:spcAft>
+                <a:spcPts val="400"/>
+              </a:spcAft>
+            </a:pPr>
+            <a:r>
+              <a:rPr sz="1000" b="0" i="0">
+                <a:solidFill>
+                  <a:srgbClr val="6B7280"/>
+                </a:solidFill>
+                <a:latin typeface="Calibri"/>
+              </a:rPr>
+              <a:t>EstimatingCoE | Eversource Energy | Stewards of Affordability</a:t>
+            </a:r>
+          </a:p>
+        </p:txBody>
+      </p:sp>
+      <p:sp>
+        <p:nvSpPr>
+          <p:cNvPr id="6" name="TextBox 5"/>
+          <p:cNvSpPr txBox="1"/>
+          <p:nvPr/>
+        </p:nvSpPr>
+        <p:spPr>
+          <a:xfrm>
+            <a:off x="10972800" y="6419088"/>
+            <a:ext cx="685800" cy="274320"/>
+          </a:xfrm>
+          <a:prstGeom prst="rect">
+            <a:avLst/>
+          </a:prstGeom>
+          <a:noFill/>
+        </p:spPr>
+        <p:txBody>
+          <a:bodyPr wrap="square" lIns="45720" rIns="45720" tIns="27432" bIns="27432" anchor="t">
+            <a:spAutoFit/>
+          </a:bodyPr>
+          <a:lstStyle/>
+          <a:p>
+            <a:pPr algn="r">
+              <a:lnSpc>
+                <a:spcPct val="105000"/>
+              </a:lnSpc>
+              <a:spcAft>
+                <a:spcPts val="400"/>
+              </a:spcAft>
+            </a:pPr>
+            <a:r>
+              <a:rPr sz="1000" b="0" i="0">
+                <a:solidFill>
+                  <a:srgbClr val="6B7280"/>
+                </a:solidFill>
+                <a:latin typeface="Calibri"/>
+              </a:rPr>
+              <a:t>17</a:t>
+            </a:r>
+          </a:p>
+        </p:txBody>
+      </p:sp>
+      <p:pic>
+        <p:nvPicPr>
+          <p:cNvPr id="7" name="Picture 6" descr="stats_scatter.png"/>
+          <p:cNvPicPr>
+            <a:picLocks noChangeAspect="1"/>
+          </p:cNvPicPr>
+          <p:nvPr/>
+        </p:nvPicPr>
+        <p:blipFill>
+          <a:blip r:embed="rId2"/>
+          <a:stretch>
+            <a:fillRect/>
+          </a:stretch>
+        </p:blipFill>
+        <p:spPr>
+          <a:xfrm>
+            <a:off x="457200" y="1371600"/>
+            <a:ext cx="7223760" cy="4182177"/>
+          </a:xfrm>
+          <a:prstGeom prst="rect">
+            <a:avLst/>
+          </a:prstGeom>
+        </p:spPr>
+      </p:pic>
+      <p:graphicFrame>
+        <p:nvGraphicFramePr>
+          <p:cNvPr id="8" name="Table 7"/>
+          <p:cNvGraphicFramePr>
+            <a:graphicFrameLocks noGrp="1"/>
+          </p:cNvGraphicFramePr>
+          <p:nvPr/>
+        </p:nvGraphicFramePr>
+        <p:xfrm>
+          <a:off x="7863840" y="1417320"/>
+          <a:ext cx="3840480" cy="2103120"/>
+        </p:xfrm>
+        <a:graphic>
+          <a:graphicData uri="http://schemas.openxmlformats.org/drawingml/2006/table">
+            <a:tbl>
+              <a:tblPr firstRow="1" bandRow="1">
+                <a:tableStyleId>{5C22544A-7EE6-4342-B048-85BDC9FD1C3A}</a:tableStyleId>
+              </a:tblPr>
+              <a:tblGrid>
+                <a:gridCol w="1645920"/>
+                <a:gridCol w="1188720"/>
+                <a:gridCol w="1005840"/>
+              </a:tblGrid>
+              <a:tr h="420624">
+                <a:tc>
+                  <a:txBody>
+                    <a:bodyPr/>
+                    <a:lstStyle/>
+                    <a:p>
+                      <a:r>
+                        <a:rPr sz="1100" b="1">
+                          <a:solidFill>
+                            <a:srgbClr val="FFFFFF"/>
+                          </a:solidFill>
+                          <a:latin typeface="Calibri"/>
+                        </a:rPr>
+                        <a:t>Term</a:t>
+                      </a:r>
+                    </a:p>
+                  </a:txBody>
+                  <a:tcPr marL="54864" marR="54864" marT="27432" marB="27432">
+                    <a:solidFill>
+                      <a:srgbClr val="001E60"/>
+                    </a:solidFill>
+                  </a:tcPr>
+                </a:tc>
+                <a:tc>
+                  <a:txBody>
+                    <a:bodyPr/>
+                    <a:lstStyle/>
+                    <a:p>
+                      <a:pPr algn="r"/>
+                      <a:r>
+                        <a:rPr sz="1100" b="1">
+                          <a:solidFill>
+                            <a:srgbClr val="FFFFFF"/>
+                          </a:solidFill>
+                          <a:latin typeface="Calibri"/>
+                        </a:rPr>
+                        <a:t>Coefficient</a:t>
+                      </a:r>
+                    </a:p>
+                  </a:txBody>
+                  <a:tcPr marL="54864" marR="54864" marT="27432" marB="27432">
+                    <a:solidFill>
+                      <a:srgbClr val="001E60"/>
+                    </a:solidFill>
+                  </a:tcPr>
+                </a:tc>
+                <a:tc>
+                  <a:txBody>
+                    <a:bodyPr/>
+                    <a:lstStyle/>
+                    <a:p>
+                      <a:pPr algn="r"/>
+                      <a:r>
+                        <a:rPr sz="1100" b="1">
+                          <a:solidFill>
+                            <a:srgbClr val="FFFFFF"/>
+                          </a:solidFill>
+                          <a:latin typeface="Calibri"/>
+                        </a:rPr>
+                        <a:t>p</a:t>
+                      </a:r>
+                    </a:p>
+                  </a:txBody>
+                  <a:tcPr marL="54864" marR="54864" marT="27432" marB="27432">
+                    <a:solidFill>
+                      <a:srgbClr val="001E60"/>
+                    </a:solidFill>
+                  </a:tcPr>
+                </a:tc>
+              </a:tr>
+              <a:tr h="420624">
+                <a:tc>
+                  <a:txBody>
+                    <a:bodyPr/>
+                    <a:lstStyle/>
+                    <a:p>
+                      <a:r>
+                        <a:rPr sz="1100" b="0">
+                          <a:solidFill>
+                            <a:srgbClr val="1F2A44"/>
+                          </a:solidFill>
+                          <a:latin typeface="Calibri"/>
+                        </a:rPr>
+                        <a:t>Size (ln MWh)</a:t>
+                      </a:r>
+                    </a:p>
+                  </a:txBody>
+                  <a:tcPr marL="54864" marR="54864" marT="27432" marB="27432" anchor="ctr">
+                    <a:solidFill>
+                      <a:srgbClr val="FFFFFF"/>
+                    </a:solidFill>
+                  </a:tcPr>
+                </a:tc>
+                <a:tc>
+                  <a:txBody>
+                    <a:bodyPr/>
+                    <a:lstStyle/>
+                    <a:p>
+                      <a:pPr algn="r"/>
+                      <a:r>
+                        <a:rPr sz="1100" b="0">
+                          <a:solidFill>
+                            <a:srgbClr val="1F2A44"/>
+                          </a:solidFill>
+                          <a:latin typeface="Calibri"/>
+                        </a:rPr>
+                        <a:t>-0.17</a:t>
+                      </a:r>
+                    </a:p>
+                  </a:txBody>
+                  <a:tcPr marL="54864" marR="54864" marT="27432" marB="27432" anchor="ctr">
+                    <a:solidFill>
+                      <a:srgbClr val="FFFFFF"/>
+                    </a:solidFill>
+                  </a:tcPr>
+                </a:tc>
+                <a:tc>
+                  <a:txBody>
+                    <a:bodyPr/>
+                    <a:lstStyle/>
+                    <a:p>
+                      <a:pPr algn="r"/>
+                      <a:r>
+                        <a:rPr sz="1100" b="0">
+                          <a:solidFill>
+                            <a:srgbClr val="1F2A44"/>
+                          </a:solidFill>
+                          <a:latin typeface="Calibri"/>
+                        </a:rPr>
+                        <a:t>0.012</a:t>
+                      </a:r>
+                    </a:p>
+                  </a:txBody>
+                  <a:tcPr marL="54864" marR="54864" marT="27432" marB="27432" anchor="ctr">
+                    <a:solidFill>
+                      <a:srgbClr val="FFFFFF"/>
+                    </a:solidFill>
+                  </a:tcPr>
+                </a:tc>
+              </a:tr>
+              <a:tr h="420624">
+                <a:tc>
+                  <a:txBody>
+                    <a:bodyPr/>
+                    <a:lstStyle/>
+                    <a:p>
+                      <a:r>
+                        <a:rPr sz="1100" b="0">
+                          <a:solidFill>
+                            <a:srgbClr val="1F2A44"/>
+                          </a:solidFill>
+                          <a:latin typeface="Calibri"/>
+                        </a:rPr>
+                        <a:t>Duration (ln h)</a:t>
+                      </a:r>
+                    </a:p>
+                  </a:txBody>
+                  <a:tcPr marL="54864" marR="54864" marT="27432" marB="27432" anchor="ctr">
+                    <a:solidFill>
+                      <a:srgbClr val="F2F4F8"/>
+                    </a:solidFill>
+                  </a:tcPr>
+                </a:tc>
+                <a:tc>
+                  <a:txBody>
+                    <a:bodyPr/>
+                    <a:lstStyle/>
+                    <a:p>
+                      <a:pPr algn="r"/>
+                      <a:r>
+                        <a:rPr sz="1100" b="0">
+                          <a:solidFill>
+                            <a:srgbClr val="1F2A44"/>
+                          </a:solidFill>
+                          <a:latin typeface="Calibri"/>
+                        </a:rPr>
+                        <a:t>-0.29</a:t>
+                      </a:r>
+                    </a:p>
+                  </a:txBody>
+                  <a:tcPr marL="54864" marR="54864" marT="27432" marB="27432" anchor="ctr">
+                    <a:solidFill>
+                      <a:srgbClr val="F2F4F8"/>
+                    </a:solidFill>
+                  </a:tcPr>
+                </a:tc>
+                <a:tc>
+                  <a:txBody>
+                    <a:bodyPr/>
+                    <a:lstStyle/>
+                    <a:p>
+                      <a:pPr algn="r"/>
+                      <a:r>
+                        <a:rPr sz="1100" b="0">
+                          <a:solidFill>
+                            <a:srgbClr val="1F2A44"/>
+                          </a:solidFill>
+                          <a:latin typeface="Calibri"/>
+                        </a:rPr>
+                        <a:t>0.016</a:t>
+                      </a:r>
+                    </a:p>
+                  </a:txBody>
+                  <a:tcPr marL="54864" marR="54864" marT="27432" marB="27432" anchor="ctr">
+                    <a:solidFill>
+                      <a:srgbClr val="F2F4F8"/>
+                    </a:solidFill>
+                  </a:tcPr>
+                </a:tc>
+              </a:tr>
+              <a:tr h="420624">
+                <a:tc>
+                  <a:txBody>
+                    <a:bodyPr/>
+                    <a:lstStyle/>
+                    <a:p>
+                      <a:r>
+                        <a:rPr sz="1100" b="0">
+                          <a:solidFill>
+                            <a:srgbClr val="1F2A44"/>
+                          </a:solidFill>
+                          <a:latin typeface="Calibri"/>
+                        </a:rPr>
+                        <a:t>Year</a:t>
+                      </a:r>
+                    </a:p>
+                  </a:txBody>
+                  <a:tcPr marL="54864" marR="54864" marT="27432" marB="27432" anchor="ctr">
+                    <a:solidFill>
+                      <a:srgbClr val="FFFFFF"/>
+                    </a:solidFill>
+                  </a:tcPr>
+                </a:tc>
+                <a:tc>
+                  <a:txBody>
+                    <a:bodyPr/>
+                    <a:lstStyle/>
+                    <a:p>
+                      <a:pPr algn="r"/>
+                      <a:r>
+                        <a:rPr sz="1100" b="0">
+                          <a:solidFill>
+                            <a:srgbClr val="1F2A44"/>
+                          </a:solidFill>
+                          <a:latin typeface="Calibri"/>
+                        </a:rPr>
+                        <a:t>+0.015</a:t>
+                      </a:r>
+                    </a:p>
+                  </a:txBody>
+                  <a:tcPr marL="54864" marR="54864" marT="27432" marB="27432" anchor="ctr">
+                    <a:solidFill>
+                      <a:srgbClr val="FFFFFF"/>
+                    </a:solidFill>
+                  </a:tcPr>
+                </a:tc>
+                <a:tc>
+                  <a:txBody>
+                    <a:bodyPr/>
+                    <a:lstStyle/>
+                    <a:p>
+                      <a:pPr algn="r"/>
+                      <a:r>
+                        <a:rPr sz="1100" b="0">
+                          <a:solidFill>
+                            <a:srgbClr val="1F2A44"/>
+                          </a:solidFill>
+                          <a:latin typeface="Calibri"/>
+                        </a:rPr>
+                        <a:t>0.68</a:t>
+                      </a:r>
+                    </a:p>
+                  </a:txBody>
+                  <a:tcPr marL="54864" marR="54864" marT="27432" marB="27432" anchor="ctr">
+                    <a:solidFill>
+                      <a:srgbClr val="FFFFFF"/>
+                    </a:solidFill>
+                  </a:tcPr>
+                </a:tc>
+              </a:tr>
+              <a:tr h="420624">
+                <a:tc>
+                  <a:txBody>
+                    <a:bodyPr/>
+                    <a:lstStyle/>
+                    <a:p>
+                      <a:r>
+                        <a:rPr sz="1100" b="0">
+                          <a:solidFill>
+                            <a:srgbClr val="1F2A44"/>
+                          </a:solidFill>
+                          <a:latin typeface="Calibri"/>
+                        </a:rPr>
+                        <a:t>R-squared</a:t>
+                      </a:r>
+                    </a:p>
+                  </a:txBody>
+                  <a:tcPr marL="54864" marR="54864" marT="27432" marB="27432" anchor="ctr">
+                    <a:solidFill>
+                      <a:srgbClr val="F2F4F8"/>
+                    </a:solidFill>
+                  </a:tcPr>
+                </a:tc>
+                <a:tc>
+                  <a:txBody>
+                    <a:bodyPr/>
+                    <a:lstStyle/>
+                    <a:p>
+                      <a:pPr algn="r"/>
+                      <a:r>
+                        <a:rPr sz="1100" b="0">
+                          <a:solidFill>
+                            <a:srgbClr val="1F2A44"/>
+                          </a:solidFill>
+                          <a:latin typeface="Calibri"/>
+                        </a:rPr>
+                        <a:t>0.65</a:t>
+                      </a:r>
+                    </a:p>
+                  </a:txBody>
+                  <a:tcPr marL="54864" marR="54864" marT="27432" marB="27432" anchor="ctr">
+                    <a:solidFill>
+                      <a:srgbClr val="F2F4F8"/>
+                    </a:solidFill>
+                  </a:tcPr>
+                </a:tc>
+                <a:tc>
+                  <a:txBody>
+                    <a:bodyPr/>
+                    <a:lstStyle/>
+                    <a:p>
+                      <a:pPr algn="r"/>
+                      <a:r>
+                        <a:rPr sz="1100" b="0">
+                          <a:solidFill>
+                            <a:srgbClr val="1F2A44"/>
+                          </a:solidFill>
+                          <a:latin typeface="Calibri"/>
+                        </a:rPr>
+                        <a:t>n = 26</a:t>
+                      </a:r>
+                    </a:p>
+                  </a:txBody>
+                  <a:tcPr marL="54864" marR="54864" marT="27432" marB="27432" anchor="ctr">
+                    <a:solidFill>
+                      <a:srgbClr val="F2F4F8"/>
+                    </a:solidFill>
+                  </a:tcPr>
+                </a:tc>
+              </a:tr>
+            </a:tbl>
+          </a:graphicData>
+        </a:graphic>
+      </p:graphicFrame>
+      <p:sp>
+        <p:nvSpPr>
+          <p:cNvPr id="9" name="TextBox 8"/>
+          <p:cNvSpPr txBox="1"/>
+          <p:nvPr/>
+        </p:nvSpPr>
+        <p:spPr>
+          <a:xfrm>
+            <a:off x="7863840" y="3703320"/>
+            <a:ext cx="3840480" cy="2560320"/>
+          </a:xfrm>
+          <a:prstGeom prst="rect">
+            <a:avLst/>
+          </a:prstGeom>
+          <a:noFill/>
+        </p:spPr>
+        <p:txBody>
+          <a:bodyPr wrap="square" lIns="45720">
+            <a:spAutoFit/>
+          </a:bodyPr>
+          <a:lstStyle/>
+          <a:p>
+            <a:pPr>
+              <a:lnSpc>
+                <a:spcPct val="105000"/>
+              </a:lnSpc>
+              <a:spcAft>
+                <a:spcPts val="500"/>
+              </a:spcAft>
+            </a:pPr>
+            <a:r>
+              <a:rPr sz="1200">
+                <a:solidFill>
+                  <a:srgbClr val="FFC72C"/>
+                </a:solidFill>
+                <a:latin typeface="Calibri"/>
+              </a:rPr>
+              <a:t>▪  </a:t>
+            </a:r>
+            <a:r>
+              <a:rPr b="1" sz="1200">
+                <a:solidFill>
+                  <a:srgbClr val="1F2A44"/>
+                </a:solidFill>
+                <a:latin typeface="Calibri"/>
+              </a:rPr>
+              <a:t>20 MWh, 2-h, 2028 prediction: </a:t>
+            </a:r>
+            <a:r>
+              <a:rPr sz="1200">
+                <a:solidFill>
+                  <a:srgbClr val="1F2A44"/>
+                </a:solidFill>
+                <a:latin typeface="Calibri"/>
+              </a:rPr>
+              <a:t>$1,116/kWh, 80% interval $611 to $2,037.</a:t>
+            </a:r>
+          </a:p>
+          <a:p>
+            <a:pPr>
+              <a:lnSpc>
+                <a:spcPct val="105000"/>
+              </a:lnSpc>
+              <a:spcAft>
+                <a:spcPts val="500"/>
+              </a:spcAft>
+            </a:pPr>
+            <a:r>
+              <a:rPr sz="1200">
+                <a:solidFill>
+                  <a:srgbClr val="FFC72C"/>
+                </a:solidFill>
+                <a:latin typeface="Calibri"/>
+              </a:rPr>
+              <a:t>▪  </a:t>
+            </a:r>
+            <a:r>
+              <a:rPr b="1" sz="1200">
+                <a:solidFill>
+                  <a:srgbClr val="1F2A44"/>
+                </a:solidFill>
+                <a:latin typeface="Calibri"/>
+              </a:rPr>
+              <a:t>Hyde Park percentiles: </a:t>
+            </a:r>
+            <a:r>
+              <a:rPr sz="1200">
+                <a:solidFill>
+                  <a:srgbClr val="1F2A44"/>
+                </a:solidFill>
+                <a:latin typeface="Calibri"/>
+              </a:rPr>
+              <a:t>contract 10%, installed 27%, station direct 73%, approval 98%.</a:t>
+            </a:r>
+          </a:p>
+          <a:p>
+            <a:pPr>
+              <a:lnSpc>
+                <a:spcPct val="105000"/>
+              </a:lnSpc>
+              <a:spcAft>
+                <a:spcPts val="500"/>
+              </a:spcAft>
+            </a:pPr>
+            <a:r>
+              <a:rPr sz="1200">
+                <a:solidFill>
+                  <a:srgbClr val="FFC72C"/>
+                </a:solidFill>
+                <a:latin typeface="Calibri"/>
+              </a:rPr>
+              <a:t>▪  </a:t>
+            </a:r>
+            <a:r>
+              <a:rPr b="1" sz="1200">
+                <a:solidFill>
+                  <a:srgbClr val="1F2A44"/>
+                </a:solidFill>
+                <a:latin typeface="Calibri"/>
+              </a:rPr>
+              <a:t>Use as a bracket, not a price. </a:t>
+            </a:r>
+            <a:r>
+              <a:rPr sz="1200">
+                <a:solidFill>
+                  <a:srgbClr val="1F2A44"/>
+                </a:solidFill>
+                <a:latin typeface="Calibri"/>
+              </a:rPr>
+              <a:t>Residual spread is a factor of 1.4; ownership and region terms are not significant at this n.</a:t>
+            </a:r>
+          </a:p>
+        </p:txBody>
+      </p:sp>
+    </p:spTree>
+  </p:cSld>
+  <p:clrMapOvr>
+    <a:masterClrMapping/>
+  </p:clrMapOvr>
+</p:sld>
+</file>
+
+<file path=ppt/slides/slide19.xml><?xml version="1.0" encoding="utf-8"?>
+<p:sld xmlns:a="http://schemas.openxmlformats.org/drawingml/2006/main" xmlns:p="http://schemas.openxmlformats.org/presentationml/2006/main" xmlns:r="http://schemas.openxmlformats.org/officeDocument/2006/relationships">
+  <p:cSld>
+    <p:spTree>
+      <p:nvGrpSpPr>
+        <p:cNvPr id="1" name=""/>
+        <p:cNvGrpSpPr/>
+        <p:nvPr/>
+      </p:nvGrpSpPr>
+      <p:grpSpPr/>
+      <p:sp>
+        <p:nvSpPr>
+          <p:cNvPr id="2" name="Rectangle 1"/>
+          <p:cNvSpPr/>
+          <p:nvPr/>
+        </p:nvSpPr>
+        <p:spPr>
+          <a:xfrm>
+            <a:off x="0" y="0"/>
+            <a:ext cx="12191695" cy="6858000"/>
+          </a:xfrm>
+          <a:prstGeom prst="rect">
+            <a:avLst/>
+          </a:prstGeom>
+          <a:solidFill>
+            <a:srgbClr val="FFFFFF"/>
+          </a:solidFill>
+          <a:ln>
+            <a:noFill/>
+          </a:ln>
+          <a:effectLst/>
+        </p:spPr>
+        <p:style>
+          <a:lnRef idx="1">
+            <a:schemeClr val="accent1"/>
+          </a:lnRef>
+          <a:fillRef idx="3">
+            <a:schemeClr val="accent1"/>
+          </a:fillRef>
+          <a:effectRef idx="2">
+            <a:schemeClr val="accent1"/>
+          </a:effectRef>
+          <a:fontRef idx="minor">
+            <a:schemeClr val="lt1"/>
+          </a:fontRef>
+        </p:style>
+        <p:txBody>
+          <a:bodyPr rtlCol="0" anchor="ctr"/>
+          <a:lstStyle/>
+          <a:p>
+            <a:pPr algn="ctr"/>
+          </a:p>
+        </p:txBody>
+      </p:sp>
+      <p:sp>
+        <p:nvSpPr>
+          <p:cNvPr id="3" name="TextBox 2"/>
+          <p:cNvSpPr txBox="1"/>
+          <p:nvPr/>
+        </p:nvSpPr>
+        <p:spPr>
+          <a:xfrm>
+            <a:off x="548640" y="256032"/>
+            <a:ext cx="10058400" cy="274320"/>
+          </a:xfrm>
+          <a:prstGeom prst="rect">
+            <a:avLst/>
+          </a:prstGeom>
+          <a:noFill/>
+        </p:spPr>
+        <p:txBody>
+          <a:bodyPr wrap="square" lIns="45720" rIns="45720" tIns="27432" bIns="27432" anchor="t">
+            <a:spAutoFit/>
+          </a:bodyPr>
+          <a:lstStyle/>
+          <a:p>
+            <a:pPr algn="l">
+              <a:lnSpc>
+                <a:spcPct val="105000"/>
+              </a:lnSpc>
+              <a:spcAft>
+                <a:spcPts val="400"/>
+              </a:spcAft>
+            </a:pPr>
+            <a:r>
+              <a:rPr sz="1100" b="1" i="0">
+                <a:solidFill>
+                  <a:srgbClr val="6E1F2E"/>
+                </a:solidFill>
+                <a:latin typeface="Calibri"/>
+              </a:rPr>
+              <a:t>APPENDIX C. ELEMENT-LEVEL SIMULATION, 20,000 TRIALS</a:t>
+            </a:r>
+          </a:p>
+        </p:txBody>
+      </p:sp>
+      <p:sp>
+        <p:nvSpPr>
+          <p:cNvPr id="4" name="TextBox 3"/>
+          <p:cNvSpPr txBox="1"/>
+          <p:nvPr/>
+        </p:nvSpPr>
+        <p:spPr>
+          <a:xfrm>
+            <a:off x="548640" y="475488"/>
+            <a:ext cx="11064240" cy="868680"/>
+          </a:xfrm>
+          <a:prstGeom prst="rect">
+            <a:avLst/>
+          </a:prstGeom>
+          <a:noFill/>
+        </p:spPr>
+        <p:txBody>
+          <a:bodyPr wrap="square" lIns="45720" rIns="45720" tIns="27432" bIns="27432" anchor="t">
+            <a:spAutoFit/>
+          </a:bodyPr>
+          <a:lstStyle/>
+          <a:p>
+            <a:pPr algn="l">
+              <a:lnSpc>
+                <a:spcPct val="100000"/>
+              </a:lnSpc>
+              <a:spcAft>
+                <a:spcPts val="400"/>
+              </a:spcAft>
+            </a:pPr>
+            <a:r>
+              <a:rPr sz="2300" b="1" i="0">
+                <a:solidFill>
+                  <a:srgbClr val="001E60"/>
+                </a:solidFill>
+                <a:latin typeface="Georgia"/>
+              </a:rPr>
+              <a:t>Monte Carlo on the layers: the reserve is adequate, and the risk is in the ground and the station, not the battery</a:t>
+            </a:r>
+          </a:p>
+        </p:txBody>
+      </p:sp>
+      <p:sp>
+        <p:nvSpPr>
+          <p:cNvPr id="5" name="TextBox 4"/>
+          <p:cNvSpPr txBox="1"/>
+          <p:nvPr/>
+        </p:nvSpPr>
+        <p:spPr>
+          <a:xfrm>
+            <a:off x="548640" y="6419088"/>
+            <a:ext cx="8229600" cy="274320"/>
+          </a:xfrm>
+          <a:prstGeom prst="rect">
+            <a:avLst/>
+          </a:prstGeom>
+          <a:noFill/>
+        </p:spPr>
+        <p:txBody>
+          <a:bodyPr wrap="square" lIns="45720" rIns="45720" tIns="27432" bIns="27432" anchor="t">
+            <a:spAutoFit/>
+          </a:bodyPr>
+          <a:lstStyle/>
+          <a:p>
+            <a:pPr algn="l">
+              <a:lnSpc>
+                <a:spcPct val="105000"/>
+              </a:lnSpc>
+              <a:spcAft>
+                <a:spcPts val="400"/>
+              </a:spcAft>
+            </a:pPr>
+            <a:r>
+              <a:rPr sz="1000" b="0" i="0">
+                <a:solidFill>
+                  <a:srgbClr val="6B7280"/>
+                </a:solidFill>
+                <a:latin typeface="Calibri"/>
+              </a:rPr>
+              <a:t>EstimatingCoE | Eversource Energy | Stewards of Affordability</a:t>
+            </a:r>
+          </a:p>
+        </p:txBody>
+      </p:sp>
+      <p:sp>
+        <p:nvSpPr>
+          <p:cNvPr id="6" name="TextBox 5"/>
+          <p:cNvSpPr txBox="1"/>
+          <p:nvPr/>
+        </p:nvSpPr>
+        <p:spPr>
+          <a:xfrm>
+            <a:off x="10972800" y="6419088"/>
+            <a:ext cx="685800" cy="274320"/>
+          </a:xfrm>
+          <a:prstGeom prst="rect">
+            <a:avLst/>
+          </a:prstGeom>
+          <a:noFill/>
+        </p:spPr>
+        <p:txBody>
+          <a:bodyPr wrap="square" lIns="45720" rIns="45720" tIns="27432" bIns="27432" anchor="t">
+            <a:spAutoFit/>
+          </a:bodyPr>
+          <a:lstStyle/>
+          <a:p>
+            <a:pPr algn="r">
+              <a:lnSpc>
+                <a:spcPct val="105000"/>
+              </a:lnSpc>
+              <a:spcAft>
+                <a:spcPts val="400"/>
+              </a:spcAft>
+            </a:pPr>
+            <a:r>
+              <a:rPr sz="1000" b="0" i="0">
+                <a:solidFill>
+                  <a:srgbClr val="6B7280"/>
+                </a:solidFill>
+                <a:latin typeface="Calibri"/>
+              </a:rPr>
+              <a:t>18</a:t>
+            </a:r>
+          </a:p>
+        </p:txBody>
+      </p:sp>
+      <p:pic>
+        <p:nvPicPr>
+          <p:cNvPr id="7" name="Picture 6" descr="mc_hist.png"/>
+          <p:cNvPicPr>
+            <a:picLocks noChangeAspect="1"/>
+          </p:cNvPicPr>
+          <p:nvPr/>
+        </p:nvPicPr>
+        <p:blipFill>
+          <a:blip r:embed="rId2"/>
+          <a:stretch>
+            <a:fillRect/>
+          </a:stretch>
+        </p:blipFill>
+        <p:spPr>
+          <a:xfrm>
+            <a:off x="457200" y="1371600"/>
+            <a:ext cx="5852160" cy="2618072"/>
+          </a:xfrm>
+          <a:prstGeom prst="rect">
+            <a:avLst/>
+          </a:prstGeom>
+        </p:spPr>
+      </p:pic>
+      <p:pic>
+        <p:nvPicPr>
+          <p:cNvPr id="8" name="Picture 7" descr="mc_tornado.png"/>
+          <p:cNvPicPr>
+            <a:picLocks noChangeAspect="1"/>
+          </p:cNvPicPr>
+          <p:nvPr/>
+        </p:nvPicPr>
+        <p:blipFill>
+          <a:blip r:embed="rId3"/>
+          <a:stretch>
+            <a:fillRect/>
+          </a:stretch>
+        </p:blipFill>
+        <p:spPr>
+          <a:xfrm>
+            <a:off x="457200" y="4069080"/>
+            <a:ext cx="5852160" cy="2310063"/>
+          </a:xfrm>
+          <a:prstGeom prst="rect">
+            <a:avLst/>
+          </a:prstGeom>
+        </p:spPr>
+      </p:pic>
+      <p:graphicFrame>
+        <p:nvGraphicFramePr>
+          <p:cNvPr id="9" name="Table 8"/>
+          <p:cNvGraphicFramePr>
+            <a:graphicFrameLocks noGrp="1"/>
+          </p:cNvGraphicFramePr>
+          <p:nvPr/>
+        </p:nvGraphicFramePr>
+        <p:xfrm>
+          <a:off x="6583680" y="1417320"/>
+          <a:ext cx="5120640" cy="2377440"/>
+        </p:xfrm>
+        <a:graphic>
+          <a:graphicData uri="http://schemas.openxmlformats.org/drawingml/2006/table">
+            <a:tbl>
+              <a:tblPr firstRow="1" bandRow="1">
+                <a:tableStyleId>{5C22544A-7EE6-4342-B048-85BDC9FD1C3A}</a:tableStyleId>
+              </a:tblPr>
+              <a:tblGrid>
+                <a:gridCol w="2377440"/>
+                <a:gridCol w="1371600"/>
+                <a:gridCol w="1371600"/>
+              </a:tblGrid>
+              <a:tr h="396240">
+                <a:tc>
+                  <a:txBody>
+                    <a:bodyPr/>
+                    <a:lstStyle/>
+                    <a:p>
+                      <a:r>
+                        <a:rPr sz="1200" b="1">
+                          <a:solidFill>
+                            <a:srgbClr val="FFFFFF"/>
+                          </a:solidFill>
+                          <a:latin typeface="Calibri"/>
+                        </a:rPr>
+                        <a:t/>
+                      </a:r>
+                    </a:p>
+                  </a:txBody>
+                  <a:tcPr marL="54864" marR="54864" marT="27432" marB="27432">
+                    <a:solidFill>
+                      <a:srgbClr val="001E60"/>
+                    </a:solidFill>
+                  </a:tcPr>
+                </a:tc>
+                <a:tc>
+                  <a:txBody>
+                    <a:bodyPr/>
+                    <a:lstStyle/>
+                    <a:p>
+                      <a:pPr algn="r"/>
+                      <a:r>
+                        <a:rPr sz="1200" b="1">
+                          <a:solidFill>
+                            <a:srgbClr val="FFFFFF"/>
+                          </a:solidFill>
+                          <a:latin typeface="Calibri"/>
+                        </a:rPr>
+                        <a:t>Base ranges</a:t>
+                      </a:r>
+                    </a:p>
+                  </a:txBody>
+                  <a:tcPr marL="54864" marR="54864" marT="27432" marB="27432">
+                    <a:solidFill>
+                      <a:srgbClr val="001E60"/>
+                    </a:solidFill>
+                  </a:tcPr>
+                </a:tc>
+                <a:tc>
+                  <a:txBody>
+                    <a:bodyPr/>
+                    <a:lstStyle/>
+                    <a:p>
+                      <a:pPr algn="r"/>
+                      <a:r>
+                        <a:rPr sz="1200" b="1">
+                          <a:solidFill>
+                            <a:srgbClr val="FFFFFF"/>
+                          </a:solidFill>
+                          <a:latin typeface="Calibri"/>
+                        </a:rPr>
+                        <a:t>Wide ranges</a:t>
+                      </a:r>
+                    </a:p>
+                  </a:txBody>
+                  <a:tcPr marL="54864" marR="54864" marT="27432" marB="27432">
+                    <a:solidFill>
+                      <a:srgbClr val="001E60"/>
+                    </a:solidFill>
+                  </a:tcPr>
+                </a:tc>
+              </a:tr>
+              <a:tr h="396240">
+                <a:tc>
+                  <a:txBody>
+                    <a:bodyPr/>
+                    <a:lstStyle/>
+                    <a:p>
+                      <a:r>
+                        <a:rPr sz="1200" b="0">
+                          <a:solidFill>
+                            <a:srgbClr val="1F2A44"/>
+                          </a:solidFill>
+                          <a:latin typeface="Calibri"/>
+                        </a:rPr>
+                        <a:t>P50 total</a:t>
+                      </a:r>
+                    </a:p>
+                  </a:txBody>
+                  <a:tcPr marL="54864" marR="54864" marT="27432" marB="27432" anchor="ctr">
+                    <a:solidFill>
+                      <a:srgbClr val="FFFFFF"/>
+                    </a:solidFill>
+                  </a:tcPr>
+                </a:tc>
+                <a:tc>
+                  <a:txBody>
+                    <a:bodyPr/>
+                    <a:lstStyle/>
+                    <a:p>
+                      <a:pPr algn="r"/>
+                      <a:r>
+                        <a:rPr sz="1200" b="0">
+                          <a:solidFill>
+                            <a:srgbClr val="1F2A44"/>
+                          </a:solidFill>
+                          <a:latin typeface="Calibri"/>
+                        </a:rPr>
+                        <a:t>$51.3M</a:t>
+                      </a:r>
+                    </a:p>
+                  </a:txBody>
+                  <a:tcPr marL="54864" marR="54864" marT="27432" marB="27432" anchor="ctr">
+                    <a:solidFill>
+                      <a:srgbClr val="FFFFFF"/>
+                    </a:solidFill>
+                  </a:tcPr>
+                </a:tc>
+                <a:tc>
+                  <a:txBody>
+                    <a:bodyPr/>
+                    <a:lstStyle/>
+                    <a:p>
+                      <a:pPr algn="r"/>
+                      <a:r>
+                        <a:rPr sz="1200" b="0">
+                          <a:solidFill>
+                            <a:srgbClr val="1F2A44"/>
+                          </a:solidFill>
+                          <a:latin typeface="Calibri"/>
+                        </a:rPr>
+                        <a:t>$53.4M</a:t>
+                      </a:r>
+                    </a:p>
+                  </a:txBody>
+                  <a:tcPr marL="54864" marR="54864" marT="27432" marB="27432" anchor="ctr">
+                    <a:solidFill>
+                      <a:srgbClr val="FFFFFF"/>
+                    </a:solidFill>
+                  </a:tcPr>
+                </a:tc>
+              </a:tr>
+              <a:tr h="396240">
+                <a:tc>
+                  <a:txBody>
+                    <a:bodyPr/>
+                    <a:lstStyle/>
+                    <a:p>
+                      <a:r>
+                        <a:rPr sz="1200" b="0">
+                          <a:solidFill>
+                            <a:srgbClr val="1F2A44"/>
+                          </a:solidFill>
+                          <a:latin typeface="Calibri"/>
+                        </a:rPr>
+                        <a:t>P80 total</a:t>
+                      </a:r>
+                    </a:p>
+                  </a:txBody>
+                  <a:tcPr marL="54864" marR="54864" marT="27432" marB="27432" anchor="ctr">
+                    <a:solidFill>
+                      <a:srgbClr val="F2F4F8"/>
+                    </a:solidFill>
+                  </a:tcPr>
+                </a:tc>
+                <a:tc>
+                  <a:txBody>
+                    <a:bodyPr/>
+                    <a:lstStyle/>
+                    <a:p>
+                      <a:pPr algn="r"/>
+                      <a:r>
+                        <a:rPr sz="1200" b="0">
+                          <a:solidFill>
+                            <a:srgbClr val="1F2A44"/>
+                          </a:solidFill>
+                          <a:latin typeface="Calibri"/>
+                        </a:rPr>
+                        <a:t>$53.0M</a:t>
+                      </a:r>
+                    </a:p>
+                  </a:txBody>
+                  <a:tcPr marL="54864" marR="54864" marT="27432" marB="27432" anchor="ctr">
+                    <a:solidFill>
+                      <a:srgbClr val="F2F4F8"/>
+                    </a:solidFill>
+                  </a:tcPr>
+                </a:tc>
+                <a:tc>
+                  <a:txBody>
+                    <a:bodyPr/>
+                    <a:lstStyle/>
+                    <a:p>
+                      <a:pPr algn="r"/>
+                      <a:r>
+                        <a:rPr sz="1200" b="0">
+                          <a:solidFill>
+                            <a:srgbClr val="1F2A44"/>
+                          </a:solidFill>
+                          <a:latin typeface="Calibri"/>
+                        </a:rPr>
+                        <a:t>$55.9M</a:t>
+                      </a:r>
+                    </a:p>
+                  </a:txBody>
+                  <a:tcPr marL="54864" marR="54864" marT="27432" marB="27432" anchor="ctr">
+                    <a:solidFill>
+                      <a:srgbClr val="F2F4F8"/>
+                    </a:solidFill>
+                  </a:tcPr>
+                </a:tc>
+              </a:tr>
+              <a:tr h="396240">
+                <a:tc>
+                  <a:txBody>
+                    <a:bodyPr/>
+                    <a:lstStyle/>
+                    <a:p>
+                      <a:r>
+                        <a:rPr sz="1200" b="0">
+                          <a:solidFill>
+                            <a:srgbClr val="1F2A44"/>
+                          </a:solidFill>
+                          <a:latin typeface="Calibri"/>
+                        </a:rPr>
+                        <a:t>Reserve to reach P80</a:t>
+                      </a:r>
+                    </a:p>
+                  </a:txBody>
+                  <a:tcPr marL="54864" marR="54864" marT="27432" marB="27432" anchor="ctr">
+                    <a:solidFill>
+                      <a:srgbClr val="FFFFFF"/>
+                    </a:solidFill>
+                  </a:tcPr>
+                </a:tc>
+                <a:tc>
+                  <a:txBody>
+                    <a:bodyPr/>
+                    <a:lstStyle/>
+                    <a:p>
+                      <a:pPr algn="r"/>
+                      <a:r>
+                        <a:rPr sz="1200" b="0">
+                          <a:solidFill>
+                            <a:srgbClr val="1F2A44"/>
+                          </a:solidFill>
+                          <a:latin typeface="Calibri"/>
+                        </a:rPr>
+                        <a:t>$3.4M</a:t>
+                      </a:r>
+                    </a:p>
+                  </a:txBody>
+                  <a:tcPr marL="54864" marR="54864" marT="27432" marB="27432" anchor="ctr">
+                    <a:solidFill>
+                      <a:srgbClr val="FFFFFF"/>
+                    </a:solidFill>
+                  </a:tcPr>
+                </a:tc>
+                <a:tc>
+                  <a:txBody>
+                    <a:bodyPr/>
+                    <a:lstStyle/>
+                    <a:p>
+                      <a:pPr algn="r"/>
+                      <a:r>
+                        <a:rPr sz="1200" b="0">
+                          <a:solidFill>
+                            <a:srgbClr val="1F2A44"/>
+                          </a:solidFill>
+                          <a:latin typeface="Calibri"/>
+                        </a:rPr>
+                        <a:t>$6.2M</a:t>
+                      </a:r>
+                    </a:p>
+                  </a:txBody>
+                  <a:tcPr marL="54864" marR="54864" marT="27432" marB="27432" anchor="ctr">
+                    <a:solidFill>
+                      <a:srgbClr val="FFFFFF"/>
+                    </a:solidFill>
+                  </a:tcPr>
+                </a:tc>
+              </a:tr>
+              <a:tr h="396240">
+                <a:tc>
+                  <a:txBody>
+                    <a:bodyPr/>
+                    <a:lstStyle/>
+                    <a:p>
+                      <a:r>
+                        <a:rPr sz="1200" b="0">
+                          <a:solidFill>
+                            <a:srgbClr val="1F2A44"/>
+                          </a:solidFill>
+                          <a:latin typeface="Calibri"/>
+                        </a:rPr>
+                        <a:t>Carried risk + contingency</a:t>
+                      </a:r>
+                    </a:p>
+                  </a:txBody>
+                  <a:tcPr marL="54864" marR="54864" marT="27432" marB="27432" anchor="ctr">
+                    <a:solidFill>
+                      <a:srgbClr val="F2F4F8"/>
+                    </a:solidFill>
+                  </a:tcPr>
+                </a:tc>
+                <a:tc>
+                  <a:txBody>
+                    <a:bodyPr/>
+                    <a:lstStyle/>
+                    <a:p>
+                      <a:pPr algn="r"/>
+                      <a:r>
+                        <a:rPr sz="1200" b="0">
+                          <a:solidFill>
+                            <a:srgbClr val="1F2A44"/>
+                          </a:solidFill>
+                          <a:latin typeface="Calibri"/>
+                        </a:rPr>
+                        <a:t>$7.6M</a:t>
+                      </a:r>
+                    </a:p>
+                  </a:txBody>
+                  <a:tcPr marL="54864" marR="54864" marT="27432" marB="27432" anchor="ctr">
+                    <a:solidFill>
+                      <a:srgbClr val="F2F4F8"/>
+                    </a:solidFill>
+                  </a:tcPr>
+                </a:tc>
+                <a:tc>
+                  <a:txBody>
+                    <a:bodyPr/>
+                    <a:lstStyle/>
+                    <a:p>
+                      <a:pPr algn="r"/>
+                      <a:r>
+                        <a:rPr sz="1200" b="0">
+                          <a:solidFill>
+                            <a:srgbClr val="1F2A44"/>
+                          </a:solidFill>
+                          <a:latin typeface="Calibri"/>
+                        </a:rPr>
+                        <a:t>$7.6M</a:t>
+                      </a:r>
+                    </a:p>
+                  </a:txBody>
+                  <a:tcPr marL="54864" marR="54864" marT="27432" marB="27432" anchor="ctr">
+                    <a:solidFill>
+                      <a:srgbClr val="F2F4F8"/>
+                    </a:solidFill>
+                  </a:tcPr>
+                </a:tc>
+              </a:tr>
+              <a:tr h="396240">
+                <a:tc>
+                  <a:txBody>
+                    <a:bodyPr/>
+                    <a:lstStyle/>
+                    <a:p>
+                      <a:r>
+                        <a:rPr sz="1200" b="0">
+                          <a:solidFill>
+                            <a:srgbClr val="1F2A44"/>
+                          </a:solidFill>
+                          <a:latin typeface="Calibri"/>
+                        </a:rPr>
+                        <a:t>P(total &gt; $57.2M)</a:t>
+                      </a:r>
+                    </a:p>
+                  </a:txBody>
+                  <a:tcPr marL="54864" marR="54864" marT="27432" marB="27432" anchor="ctr">
+                    <a:solidFill>
+                      <a:srgbClr val="FFFFFF"/>
+                    </a:solidFill>
+                  </a:tcPr>
+                </a:tc>
+                <a:tc>
+                  <a:txBody>
+                    <a:bodyPr/>
+                    <a:lstStyle/>
+                    <a:p>
+                      <a:pPr algn="r"/>
+                      <a:r>
+                        <a:rPr sz="1200" b="0">
+                          <a:solidFill>
+                            <a:srgbClr val="1F2A44"/>
+                          </a:solidFill>
+                          <a:latin typeface="Calibri"/>
+                        </a:rPr>
+                        <a:t>0%</a:t>
+                      </a:r>
+                    </a:p>
+                  </a:txBody>
+                  <a:tcPr marL="54864" marR="54864" marT="27432" marB="27432" anchor="ctr">
+                    <a:solidFill>
+                      <a:srgbClr val="FFFFFF"/>
+                    </a:solidFill>
+                  </a:tcPr>
+                </a:tc>
+                <a:tc>
+                  <a:txBody>
+                    <a:bodyPr/>
+                    <a:lstStyle/>
+                    <a:p>
+                      <a:pPr algn="r"/>
+                      <a:r>
+                        <a:rPr sz="1200" b="0">
+                          <a:solidFill>
+                            <a:srgbClr val="1F2A44"/>
+                          </a:solidFill>
+                          <a:latin typeface="Calibri"/>
+                        </a:rPr>
+                        <a:t>10%</a:t>
+                      </a:r>
+                    </a:p>
+                  </a:txBody>
+                  <a:tcPr marL="54864" marR="54864" marT="27432" marB="27432" anchor="ctr">
+                    <a:solidFill>
+                      <a:srgbClr val="FFFFFF"/>
+                    </a:solidFill>
+                  </a:tcPr>
+                </a:tc>
+              </a:tr>
+            </a:tbl>
+          </a:graphicData>
+        </a:graphic>
+      </p:graphicFrame>
+      <p:sp>
+        <p:nvSpPr>
+          <p:cNvPr id="10" name="TextBox 9"/>
+          <p:cNvSpPr txBox="1"/>
+          <p:nvPr/>
+        </p:nvSpPr>
+        <p:spPr>
+          <a:xfrm>
+            <a:off x="6583680" y="3977639"/>
+            <a:ext cx="5120640" cy="2286000"/>
+          </a:xfrm>
+          <a:prstGeom prst="rect">
+            <a:avLst/>
+          </a:prstGeom>
+          <a:noFill/>
+        </p:spPr>
+        <p:txBody>
+          <a:bodyPr wrap="square" lIns="45720">
+            <a:spAutoFit/>
+          </a:bodyPr>
+          <a:lstStyle/>
+          <a:p>
+            <a:pPr>
+              <a:lnSpc>
+                <a:spcPct val="105000"/>
+              </a:lnSpc>
+              <a:spcAft>
+                <a:spcPts val="500"/>
+              </a:spcAft>
+            </a:pPr>
+            <a:r>
+              <a:rPr sz="1200">
+                <a:solidFill>
+                  <a:srgbClr val="FFC72C"/>
+                </a:solidFill>
+                <a:latin typeface="Calibri"/>
+              </a:rPr>
+              <a:t>▪  </a:t>
+            </a:r>
+            <a:r>
+              <a:rPr b="1" sz="1200">
+                <a:solidFill>
+                  <a:srgbClr val="1F2A44"/>
+                </a:solidFill>
+                <a:latin typeface="Calibri"/>
+              </a:rPr>
+              <a:t>Distributions </a:t>
+            </a:r>
+            <a:r>
+              <a:rPr sz="1200">
+                <a:solidFill>
+                  <a:srgbClr val="1F2A44"/>
+                </a:solidFill>
+                <a:latin typeface="Calibri"/>
+              </a:rPr>
+              <a:t>are PERT ranges on each of the nine Station 360 layers plus Station 496, indirects and AFUDC; risk register and contingency are not stacked on top (they fund the same outcomes).</a:t>
+            </a:r>
+          </a:p>
+          <a:p>
+            <a:pPr>
+              <a:lnSpc>
+                <a:spcPct val="105000"/>
+              </a:lnSpc>
+              <a:spcAft>
+                <a:spcPts val="500"/>
+              </a:spcAft>
+            </a:pPr>
+            <a:r>
+              <a:rPr sz="1200">
+                <a:solidFill>
+                  <a:srgbClr val="FFC72C"/>
+                </a:solidFill>
+                <a:latin typeface="Calibri"/>
+              </a:rPr>
+              <a:t>▪  </a:t>
+            </a:r>
+            <a:r>
+              <a:rPr b="1" sz="1200">
+                <a:solidFill>
+                  <a:srgbClr val="1F2A44"/>
+                </a:solidFill>
+                <a:latin typeface="Calibri"/>
+              </a:rPr>
+              <a:t>Estimate-to-actual uplift on comparables: </a:t>
+            </a:r>
+            <a:r>
+              <a:rPr sz="1200">
+                <a:solidFill>
+                  <a:srgbClr val="1F2A44"/>
+                </a:solidFill>
+                <a:latin typeface="Calibri"/>
+              </a:rPr>
+              <a:t>Fairhaven +64%, Provincetown +9 to +40%, Waena +37%, Regina +31%, Hyde Park Sep cycle +21%. Median about +31%; Rev 3 carries 17.9%.</a:t>
+            </a:r>
+          </a:p>
+          <a:p>
+            <a:pPr>
+              <a:lnSpc>
+                <a:spcPct val="105000"/>
+              </a:lnSpc>
+              <a:spcAft>
+                <a:spcPts val="500"/>
+              </a:spcAft>
+            </a:pPr>
+            <a:r>
+              <a:rPr sz="1200">
+                <a:solidFill>
+                  <a:srgbClr val="FFC72C"/>
+                </a:solidFill>
+                <a:latin typeface="Calibri"/>
+              </a:rPr>
+              <a:t>▪  </a:t>
+            </a:r>
+            <a:r>
+              <a:rPr b="1" sz="1200">
+                <a:solidFill>
+                  <a:srgbClr val="1F2A44"/>
+                </a:solidFill>
+                <a:latin typeface="Calibri"/>
+              </a:rPr>
+              <a:t>Next step: </a:t>
+            </a:r>
+            <a:r>
+              <a:rPr sz="1200">
+                <a:solidFill>
+                  <a:srgbClr val="1F2A44"/>
+                </a:solidFill>
+                <a:latin typeface="Calibri"/>
+              </a:rPr>
+              <a:t>replace these ranges with the project team's in a two-hour range-estimating session (AACE 41R-08) before full funding.</a:t>
             </a:r>
           </a:p>
         </p:txBody>

</xml_diff>

<commit_message>
Add the three NYCIDA-costed New York projects to the regression dataset and re-run the model (n = 29)
Size elasticity unchanged at -0.17 (p 0.012 to 0.001), duration -0.29, year insignificant, R-squared 0.645 to 0.629. Prediction for 20 MWh / 2-h / 2028 moves from $1,116 to $1,114/kWh; 80% interval narrows from $611-$2,037 to $652-$1,903. Hyde Park station-direct percentile 73% to 75%. Appendix B, memo sections 2 and 3.2, workbook Public Projects and Statistics tabs, README and research log updated; the financing floor and NYSERDA averages were not added because they are not project costs.

Co-Authored-By: Claude Fable 5.1 <noreply@anthropic.com>
Claude-Session: https://claude.ai/code/session_01YAU7MDk5K6GEm6c4td5TUq
</commit_message>
<xml_diff>
--- a/Hyde Park BESS/6) Cost Analysis Deliverables/Hyde Park BESS - Cost Analysis Deck.pptx
+++ b/Hyde Park BESS/6) Cost Analysis Deliverables/Hyde Park BESS - Cost Analysis Deck.pptx
@@ -4876,7 +4876,7 @@
           <a:lstStyle/>
           <a:p>
             <a:r>
-              <a:t>Answer to the review comment that New York has built many more of these (NineDot Energy). Sources: NYCIDA public hearing notices and inducement resolutions (edc.nyc, Mar-Apr 2024) for the Arthur Kill Road, Victory Boulevard and Maspeth project costs; NineDot and Natixis releases (Feb 2026) for the 28-project financing; NYSERDA 6 GW Energy Storage Roadmap (Dec 2022) for the retail program averages; Utility Dive and the NY-BEST/NYSEIA filing in Case 24-E-0621 for the interconnection figures; existing dataset rows for Pomona, Ozone Park and Chateaugay. The NY cohort is 2021-2027 dollars and is not re-based (2025 to 2026 at the installed index is +2%). Developer-owned rows carry developer overhead and profit but not utility indirects or AFUDC. These rows are not in the regression (n = 26), which was not re-run.</a:t>
+              <a:t>Answer to the review comment that New York has built many more of these (NineDot Energy). Sources: NYCIDA public hearing notices and inducement resolutions (edc.nyc, Mar-Apr 2024) for the Arthur Kill Road, Victory Boulevard and Maspeth project costs; NineDot and Natixis releases (Feb 2026) for the 28-project financing; NYSERDA 6 GW Energy Storage Roadmap (Dec 2022) for the retail program averages; Utility Dive and the NY-BEST/NYSEIA filing in Case 24-E-0621 for the interconnection figures; existing dataset rows for Pomona, Ozone Park and Chateaugay. The NY cohort is 2021-2027 dollars and is not re-based (2025 to 2026 at the installed index is +2%). Developer-owned rows carry developer overhead and profit but not utility indirects or AFUDC. The three NYCIDA-costed rows (Arthur Kill Road, Victory Boulevard, Maspeth) were added to the regression dataset on 2 Oct 2026 (n = 29, Appendix B); the financing floor and the NYSERDA averages are not project costs and were not. The size elasticity is unchanged at -0.17 and the prediction for 20 MWh / 2-h / 2028 moved from $1,116 to $1,114/kWh with a narrower 80% interval ($652 to $1,903).</a:t>
             </a:r>
           </a:p>
         </p:txBody>
@@ -22483,7 +22483,7 @@
                 </a:solidFill>
                 <a:latin typeface="Calibri"/>
               </a:rPr>
-              <a:t>APPENDIX B. REGRESSION ON 26 PUBLIC PROJECTS</a:t>
+              <a:t>APPENDIX B. REGRESSION ON 29 PUBLIC PROJECTS</a:t>
             </a:r>
           </a:p>
         </p:txBody>
@@ -22790,7 +22790,7 @@
                           </a:solidFill>
                           <a:latin typeface="Calibri"/>
                         </a:rPr>
-                        <a:t>0.012</a:t>
+                        <a:t>0.001</a:t>
                       </a:r>
                     </a:p>
                   </a:txBody>
@@ -22860,7 +22860,7 @@
                           </a:solidFill>
                           <a:latin typeface="Calibri"/>
                         </a:rPr>
-                        <a:t>0.016</a:t>
+                        <a:t>0.012</a:t>
                       </a:r>
                     </a:p>
                   </a:txBody>
@@ -22930,7 +22930,7 @@
                           </a:solidFill>
                           <a:latin typeface="Calibri"/>
                         </a:rPr>
-                        <a:t>0.68</a:t>
+                        <a:t>0.62</a:t>
                       </a:r>
                     </a:p>
                   </a:txBody>
@@ -22977,7 +22977,7 @@
                           </a:solidFill>
                           <a:latin typeface="Calibri"/>
                         </a:rPr>
-                        <a:t>0.65</a:t>
+                        <a:t>0.63</a:t>
                       </a:r>
                     </a:p>
                   </a:txBody>
@@ -23000,7 +23000,7 @@
                           </a:solidFill>
                           <a:latin typeface="Calibri"/>
                         </a:rPr>
-                        <a:t>n = 26</a:t>
+                        <a:t>n = 29</a:t>
                       </a:r>
                     </a:p>
                   </a:txBody>
@@ -23070,7 +23070,7 @@
                 </a:solidFill>
                 <a:latin typeface="Calibri"/>
               </a:rPr>
-              <a:t>$1,116/kWh, 80% interval $611 to $2,037.</a:t>
+              <a:t>$1,114/kWh, 80% interval $652 to $1,903.</a:t>
             </a:r>
           </a:p>
           <a:p>
@@ -23107,7 +23107,7 @@
                 </a:solidFill>
                 <a:latin typeface="Calibri"/>
               </a:rPr>
-              <a:t>contract 10%, installed 27%, station direct 73%, approval 98%.</a:t>
+              <a:t>contract 7%, installed 24%, station direct 75%, approval 99%.</a:t>
             </a:r>
           </a:p>
           <a:p>

</xml_diff>

<commit_message>
Whitepaper and BOE carry the layer escalators and the savings register; BLS escalator series pulled from the FRED and BLS APIs
- Whitepaper: new 5.3 (one escalator per layer, methods table, scaling recipe), new 8 (savings register, tier totals, Section 48E), recommendations extended, sources appended
- BOE: escalator check in 1.3 and 14 (template 3%/yr vs the published series 2023-2026), risk-register overlap in 18, E&S basis question in 19, AFUDC timing in 20, six new open items in 22
- fetch_indices.py now uses the keyless FRED CSV and BLS v2 endpoints; indices_layers_api.json holds ten BLS series 2014-2026 and overrides the search-excerpt values (results unchanged: composite 1.17x, class median $832)
- Breaker lever sized on the furnish line only; README and research log updated

Co-Authored-By: Claude Fable 5.1 <noreply@anthropic.com>
Claude-Session: https://claude.ai/code/session_01YAU7MDk5K6GEm6c4td5TUq
</commit_message>
<xml_diff>
--- a/Hyde Park BESS/6) Cost Analysis Deliverables/Hyde Park BESS - Cost Analysis Deck.pptx
+++ b/Hyde Park BESS/6) Cost Analysis Deliverables/Hyde Park BESS - Cost Analysis Deck.pptx
@@ -791,41 +791,47 @@
           </c:marker>
           <c:xVal>
             <c:numRef>
-              <c:f>Sheet1!$A$18:$A$28</c:f>
+              <c:f>Sheet1!$A$18:$A$30</c:f>
               <c:numCache>
                 <c:formatCode>General</c:formatCode>
-                <c:ptCount val="11"/>
+                <c:ptCount val="13"/>
                 <c:pt idx="0">
+                  <c:v>2014</c:v>
+                </c:pt>
+                <c:pt idx="1">
                   <c:v>2015</c:v>
                 </c:pt>
-                <c:pt idx="1">
+                <c:pt idx="2">
                   <c:v>2016</c:v>
                 </c:pt>
-                <c:pt idx="2">
+                <c:pt idx="3">
                   <c:v>2017</c:v>
                 </c:pt>
-                <c:pt idx="3">
+                <c:pt idx="4">
                   <c:v>2018</c:v>
                 </c:pt>
-                <c:pt idx="4">
+                <c:pt idx="5">
                   <c:v>2019</c:v>
                 </c:pt>
-                <c:pt idx="5">
+                <c:pt idx="6">
                   <c:v>2020</c:v>
                 </c:pt>
-                <c:pt idx="6">
+                <c:pt idx="7">
                   <c:v>2021</c:v>
                 </c:pt>
-                <c:pt idx="7">
+                <c:pt idx="8">
                   <c:v>2022</c:v>
                 </c:pt>
-                <c:pt idx="8">
+                <c:pt idx="9">
                   <c:v>2023</c:v>
                 </c:pt>
-                <c:pt idx="9">
+                <c:pt idx="10">
+                  <c:v>2024</c:v>
+                </c:pt>
+                <c:pt idx="11">
                   <c:v>2025</c:v>
                 </c:pt>
-                <c:pt idx="10">
+                <c:pt idx="12">
                   <c:v>2026</c:v>
                 </c:pt>
               </c:numCache>
@@ -833,42 +839,48 @@
           </c:xVal>
           <c:yVal>
             <c:numRef>
-              <c:f>Sheet1!$B$18:$B$28</c:f>
+              <c:f>Sheet1!$B$18:$B$30</c:f>
               <c:numCache>
                 <c:formatCode>General</c:formatCode>
-                <c:ptCount val="11"/>
+                <c:ptCount val="13"/>
                 <c:pt idx="0">
+                  <c:v>1.005</c:v>
+                </c:pt>
+                <c:pt idx="1">
                   <c:v>0.943</c:v>
                 </c:pt>
-                <c:pt idx="1">
-                  <c:v>0.914</c:v>
-                </c:pt>
                 <c:pt idx="2">
+                  <c:v>0.915</c:v>
+                </c:pt>
+                <c:pt idx="3">
                   <c:v>0.949</c:v>
                 </c:pt>
-                <c:pt idx="3">
+                <c:pt idx="4">
                   <c:v>1.0</c:v>
                 </c:pt>
-                <c:pt idx="4">
+                <c:pt idx="5">
                   <c:v>1.02</c:v>
                 </c:pt>
-                <c:pt idx="5">
+                <c:pt idx="6">
                   <c:v>1.034</c:v>
                 </c:pt>
-                <c:pt idx="6">
+                <c:pt idx="7">
                   <c:v>1.213</c:v>
                 </c:pt>
-                <c:pt idx="7">
+                <c:pt idx="8">
                   <c:v>1.632</c:v>
                 </c:pt>
-                <c:pt idx="8">
-                  <c:v>1.737</c:v>
-                </c:pt>
                 <c:pt idx="9">
-                  <c:v>1.838</c:v>
+                  <c:v>1.741</c:v>
                 </c:pt>
                 <c:pt idx="10">
-                  <c:v>1.895</c:v>
+                  <c:v>1.788</c:v>
+                </c:pt>
+                <c:pt idx="11">
+                  <c:v>1.842</c:v>
+                </c:pt>
+                <c:pt idx="12">
+                  <c:v>1.912</c:v>
                 </c:pt>
               </c:numCache>
             </c:numRef>
@@ -880,7 +892,7 @@
           <c:order val="2"/>
           <c:tx>
             <c:strRef>
-              <c:f>Sheet1!$B$30</c:f>
+              <c:f>Sheet1!$B$32</c:f>
               <c:strCache>
                 <c:ptCount val="1"/>
                 <c:pt idx="0">
@@ -912,41 +924,47 @@
           </c:marker>
           <c:xVal>
             <c:numRef>
-              <c:f>Sheet1!$A$31:$A$41</c:f>
+              <c:f>Sheet1!$A$33:$A$45</c:f>
               <c:numCache>
                 <c:formatCode>General</c:formatCode>
-                <c:ptCount val="11"/>
+                <c:ptCount val="13"/>
                 <c:pt idx="0">
+                  <c:v>2014</c:v>
+                </c:pt>
+                <c:pt idx="1">
                   <c:v>2015</c:v>
                 </c:pt>
-                <c:pt idx="1">
+                <c:pt idx="2">
                   <c:v>2016</c:v>
                 </c:pt>
-                <c:pt idx="2">
+                <c:pt idx="3">
                   <c:v>2017</c:v>
                 </c:pt>
-                <c:pt idx="3">
+                <c:pt idx="4">
                   <c:v>2018</c:v>
                 </c:pt>
-                <c:pt idx="4">
+                <c:pt idx="5">
                   <c:v>2019</c:v>
                 </c:pt>
-                <c:pt idx="5">
+                <c:pt idx="6">
                   <c:v>2020</c:v>
                 </c:pt>
-                <c:pt idx="6">
+                <c:pt idx="7">
                   <c:v>2021</c:v>
                 </c:pt>
-                <c:pt idx="7">
+                <c:pt idx="8">
                   <c:v>2022</c:v>
                 </c:pt>
-                <c:pt idx="8">
+                <c:pt idx="9">
                   <c:v>2023</c:v>
                 </c:pt>
-                <c:pt idx="9">
+                <c:pt idx="10">
+                  <c:v>2024</c:v>
+                </c:pt>
+                <c:pt idx="11">
                   <c:v>2025</c:v>
                 </c:pt>
-                <c:pt idx="10">
+                <c:pt idx="12">
                   <c:v>2026</c:v>
                 </c:pt>
               </c:numCache>
@@ -954,42 +972,48 @@
           </c:xVal>
           <c:yVal>
             <c:numRef>
-              <c:f>Sheet1!$B$31:$B$41</c:f>
+              <c:f>Sheet1!$B$33:$B$45</c:f>
               <c:numCache>
                 <c:formatCode>General</c:formatCode>
-                <c:ptCount val="11"/>
+                <c:ptCount val="13"/>
                 <c:pt idx="0">
+                  <c:v>0.968</c:v>
+                </c:pt>
+                <c:pt idx="1">
                   <c:v>0.973</c:v>
                 </c:pt>
-                <c:pt idx="1">
+                <c:pt idx="2">
                   <c:v>0.976</c:v>
                 </c:pt>
-                <c:pt idx="2">
+                <c:pt idx="3">
                   <c:v>0.981</c:v>
                 </c:pt>
-                <c:pt idx="3">
+                <c:pt idx="4">
                   <c:v>1.0</c:v>
                 </c:pt>
-                <c:pt idx="4">
+                <c:pt idx="5">
                   <c:v>1.027</c:v>
                 </c:pt>
-                <c:pt idx="5">
+                <c:pt idx="6">
                   <c:v>1.047</c:v>
                 </c:pt>
-                <c:pt idx="6">
+                <c:pt idx="7">
                   <c:v>1.096</c:v>
                 </c:pt>
-                <c:pt idx="7">
+                <c:pt idx="8">
                   <c:v>1.303</c:v>
                 </c:pt>
-                <c:pt idx="8">
-                  <c:v>1.426</c:v>
-                </c:pt>
                 <c:pt idx="9">
-                  <c:v>1.689</c:v>
+                  <c:v>1.429</c:v>
                 </c:pt>
                 <c:pt idx="10">
-                  <c:v>1.831</c:v>
+                  <c:v>1.525</c:v>
+                </c:pt>
+                <c:pt idx="11">
+                  <c:v>1.665</c:v>
+                </c:pt>
+                <c:pt idx="12">
+                  <c:v>1.824</c:v>
                 </c:pt>
               </c:numCache>
             </c:numRef>
@@ -1001,7 +1025,7 @@
           <c:order val="3"/>
           <c:tx>
             <c:strRef>
-              <c:f>Sheet1!$B$43</c:f>
+              <c:f>Sheet1!$B$47</c:f>
               <c:strCache>
                 <c:ptCount val="1"/>
                 <c:pt idx="0">
@@ -1033,7 +1057,7 @@
           </c:marker>
           <c:xVal>
             <c:numRef>
-              <c:f>Sheet1!$A$44:$A$53</c:f>
+              <c:f>Sheet1!$A$48:$A$57</c:f>
               <c:numCache>
                 <c:formatCode>General</c:formatCode>
                 <c:ptCount val="10"/>
@@ -1072,7 +1096,7 @@
           </c:xVal>
           <c:yVal>
             <c:numRef>
-              <c:f>Sheet1!$B$44:$B$53</c:f>
+              <c:f>Sheet1!$B$48:$B$57</c:f>
               <c:numCache>
                 <c:formatCode>General</c:formatCode>
                 <c:ptCount val="10"/>
@@ -1116,7 +1140,7 @@
           <c:order val="4"/>
           <c:tx>
             <c:strRef>
-              <c:f>Sheet1!$B$55</c:f>
+              <c:f>Sheet1!$B$59</c:f>
               <c:strCache>
                 <c:ptCount val="1"/>
                 <c:pt idx="0">
@@ -1148,7 +1172,7 @@
           </c:marker>
           <c:xVal>
             <c:numRef>
-              <c:f>Sheet1!$A$56:$A$61</c:f>
+              <c:f>Sheet1!$A$60:$A$65</c:f>
               <c:numCache>
                 <c:formatCode>General</c:formatCode>
                 <c:ptCount val="6"/>
@@ -1175,7 +1199,7 @@
           </c:xVal>
           <c:yVal>
             <c:numRef>
-              <c:f>Sheet1!$B$56:$B$61</c:f>
+              <c:f>Sheet1!$B$60:$B$65</c:f>
               <c:numCache>
                 <c:formatCode>General</c:formatCode>
                 <c:ptCount val="6"/>
@@ -1207,7 +1231,7 @@
           <c:order val="5"/>
           <c:tx>
             <c:strRef>
-              <c:f>Sheet1!$B$63</c:f>
+              <c:f>Sheet1!$B$67</c:f>
               <c:strCache>
                 <c:ptCount val="1"/>
                 <c:pt idx="0">
@@ -1239,41 +1263,47 @@
           </c:marker>
           <c:xVal>
             <c:numRef>
-              <c:f>Sheet1!$A$64:$A$74</c:f>
+              <c:f>Sheet1!$A$68:$A$80</c:f>
               <c:numCache>
                 <c:formatCode>General</c:formatCode>
-                <c:ptCount val="11"/>
+                <c:ptCount val="13"/>
                 <c:pt idx="0">
+                  <c:v>2014</c:v>
+                </c:pt>
+                <c:pt idx="1">
                   <c:v>2015</c:v>
                 </c:pt>
-                <c:pt idx="1">
+                <c:pt idx="2">
                   <c:v>2016</c:v>
                 </c:pt>
-                <c:pt idx="2">
+                <c:pt idx="3">
                   <c:v>2017</c:v>
                 </c:pt>
-                <c:pt idx="3">
+                <c:pt idx="4">
                   <c:v>2018</c:v>
                 </c:pt>
-                <c:pt idx="4">
+                <c:pt idx="5">
                   <c:v>2019</c:v>
                 </c:pt>
-                <c:pt idx="5">
+                <c:pt idx="6">
                   <c:v>2020</c:v>
                 </c:pt>
-                <c:pt idx="6">
+                <c:pt idx="7">
                   <c:v>2021</c:v>
                 </c:pt>
-                <c:pt idx="7">
+                <c:pt idx="8">
                   <c:v>2022</c:v>
                 </c:pt>
-                <c:pt idx="8">
+                <c:pt idx="9">
                   <c:v>2023</c:v>
                 </c:pt>
-                <c:pt idx="9">
+                <c:pt idx="10">
+                  <c:v>2024</c:v>
+                </c:pt>
+                <c:pt idx="11">
                   <c:v>2025</c:v>
                 </c:pt>
-                <c:pt idx="10">
+                <c:pt idx="12">
                   <c:v>2026</c:v>
                 </c:pt>
               </c:numCache>
@@ -1281,42 +1311,48 @@
           </c:xVal>
           <c:yVal>
             <c:numRef>
-              <c:f>Sheet1!$B$64:$B$74</c:f>
+              <c:f>Sheet1!$B$68:$B$80</c:f>
               <c:numCache>
                 <c:formatCode>General</c:formatCode>
-                <c:ptCount val="11"/>
+                <c:ptCount val="13"/>
                 <c:pt idx="0">
+                  <c:v>0.911</c:v>
+                </c:pt>
+                <c:pt idx="1">
                   <c:v>0.935</c:v>
                 </c:pt>
-                <c:pt idx="1">
+                <c:pt idx="2">
                   <c:v>0.953</c:v>
                 </c:pt>
-                <c:pt idx="2">
+                <c:pt idx="3">
                   <c:v>0.975</c:v>
                 </c:pt>
-                <c:pt idx="3">
+                <c:pt idx="4">
                   <c:v>1.0</c:v>
                 </c:pt>
-                <c:pt idx="4">
+                <c:pt idx="5">
                   <c:v>1.026</c:v>
                 </c:pt>
-                <c:pt idx="5">
+                <c:pt idx="6">
                   <c:v>1.03</c:v>
                 </c:pt>
-                <c:pt idx="6">
-                  <c:v>1.061</c:v>
-                </c:pt>
                 <c:pt idx="7">
+                  <c:v>1.06</c:v>
+                </c:pt>
+                <c:pt idx="8">
                   <c:v>1.119</c:v>
                 </c:pt>
-                <c:pt idx="8">
-                  <c:v>1.16</c:v>
-                </c:pt>
                 <c:pt idx="9">
-                  <c:v>1.227</c:v>
+                  <c:v>1.161</c:v>
                 </c:pt>
                 <c:pt idx="10">
-                  <c:v>1.261</c:v>
+                  <c:v>1.19</c:v>
+                </c:pt>
+                <c:pt idx="11">
+                  <c:v>1.222</c:v>
+                </c:pt>
+                <c:pt idx="12">
+                  <c:v>1.247</c:v>
                 </c:pt>
               </c:numCache>
             </c:numRef>
@@ -1328,7 +1364,7 @@
           <c:order val="6"/>
           <c:tx>
             <c:strRef>
-              <c:f>Sheet1!$B$76</c:f>
+              <c:f>Sheet1!$B$82</c:f>
               <c:strCache>
                 <c:ptCount val="1"/>
                 <c:pt idx="0">
@@ -1361,7 +1397,7 @@
           </c:marker>
           <c:xVal>
             <c:numRef>
-              <c:f>Sheet1!$A$77:$A$79</c:f>
+              <c:f>Sheet1!$A$83:$A$85</c:f>
               <c:numCache>
                 <c:formatCode>General</c:formatCode>
                 <c:ptCount val="3"/>
@@ -1379,7 +1415,7 @@
           </c:xVal>
           <c:yVal>
             <c:numRef>
-              <c:f>Sheet1!$B$77:$B$79</c:f>
+              <c:f>Sheet1!$B$83:$B$85</c:f>
               <c:numCache>
                 <c:formatCode>General</c:formatCode>
                 <c:ptCount val="3"/>
@@ -2782,7 +2818,7 @@
                   <c:v>B4  Battery install crew build-up   $0.7 to 0.9M</c:v>
                 </c:pt>
                 <c:pt idx="9">
-                  <c:v>B5  Breaker package price   $0.4 to 0.9M</c:v>
+                  <c:v>B5  Breaker package price   $0.4 to 0.8M</c:v>
                 </c:pt>
                 <c:pt idx="10">
                   <c:v>B6  GSU package price   $0.3 to 0.6M</c:v>
@@ -2833,7 +2869,7 @@
                   <c:v>0.71</c:v>
                 </c:pt>
                 <c:pt idx="9">
-                  <c:v>0.43</c:v>
+                  <c:v>0.38</c:v>
                 </c:pt>
                 <c:pt idx="10">
                   <c:v>0.31</c:v>
@@ -3010,7 +3046,7 @@
                   <c:v>B4  Battery install crew build-up   $0.7 to 0.9M</c:v>
                 </c:pt>
                 <c:pt idx="9">
-                  <c:v>B5  Breaker package price   $0.4 to 0.9M</c:v>
+                  <c:v>B5  Breaker package price   $0.4 to 0.8M</c:v>
                 </c:pt>
                 <c:pt idx="10">
                   <c:v>B6  GSU package price   $0.3 to 0.6M</c:v>
@@ -3061,7 +3097,7 @@
                   <c:v>0.17</c:v>
                 </c:pt>
                 <c:pt idx="9">
-                  <c:v>0.43</c:v>
+                  <c:v>0.38</c:v>
                 </c:pt>
                 <c:pt idx="10">
                   <c:v>0.31</c:v>
@@ -7334,7 +7370,7 @@
           <a:lstStyle/>
           <a:p>
             <a:r>
-              <a:t>Narrative 1, step 1. The two-component model on slides 12 and 14 to 16 uses one battery index and one construction index. This slide replaces the construction index with the published series that fits each layer: ECI construction compensation for labor-driven layers (B, G), the IBEW Local 103 journeyman rate for the labor-driven layers (B, F, G), the BLS producer price index for power and distribution transformers (C), the PPI for switchgear (D), the ENR Construction Cost Index for civil (E) and the PPI for engineering services (H). Weights are the Rev 3 loaded layers A to I. Factors for a 2018 project: composite 1.174, two-component 1.189, naive battery 0.733, Handy-Whitman only 1.493. Series values retrieved from search excerpts of the publishers' releases and tagged in indices_layers.json; fetch_indices.py pulls the same series from the FRED and BLS APIs once the environment allows those hosts. Verify before external use.</a:t>
+              <a:t>Narrative 1, step 1. The two-component model on slides 12 and 14 to 16 uses one battery index and one construction index. This slide replaces the construction index with the published series that fits each layer: ECI construction compensation for labor-driven layers (B, G), the IBEW Local 103 journeyman rate for the labor-driven layers (B, F, G), the BLS producer price index for power and distribution transformers (C), the PPI for switchgear (D), the ENR Construction Cost Index for civil (E) and the PPI for engineering services (H). Weights are the Rev 3 loaded layers A to I. Factors for a 2018 project: composite 1.172, two-component 1.189, naive battery 0.733, Handy-Whitman only 1.493. Series values retrieved from search excerpts of the publishers' releases and tagged in indices_layers.json; fetch_indices.py pulls the same series from the FRED and BLS APIs once the environment allows those hosts. Verify before external use.</a:t>
             </a:r>
           </a:p>
         </p:txBody>
@@ -20361,7 +20397,7 @@
                           </a:solidFill>
                           <a:latin typeface="Calibri"/>
                         </a:rPr>
-                        <a:t>1.89x</a:t>
+                        <a:t>1.91x</a:t>
                       </a:r>
                     </a:p>
                   </a:txBody>
@@ -20453,7 +20489,7 @@
                           </a:solidFill>
                           <a:latin typeface="Calibri"/>
                         </a:rPr>
-                        <a:t>1.83x</a:t>
+                        <a:t>1.82x</a:t>
                       </a:r>
                     </a:p>
                   </a:txBody>
@@ -20821,7 +20857,7 @@
                           </a:solidFill>
                           <a:latin typeface="Calibri"/>
                         </a:rPr>
-                        <a:t>1.26x</a:t>
+                        <a:t>1.25x</a:t>
                       </a:r>
                     </a:p>
                   </a:txBody>
@@ -21126,7 +21162,7 @@
                 </a:solidFill>
                 <a:latin typeface="Calibri"/>
               </a:rPr>
-              <a:t>Five non-battery escalators sit between 1.26x and 1.89x since 2018; the battery sits at 0.73x. </a:t>
+              <a:t>Five non-battery escalators sit between 1.25x and 1.91x since 2018; the battery sits at 0.73x. </a:t>
             </a:r>
             <a:r>
               <a:rPr sz="1100">
@@ -21135,7 +21171,7 @@
                 </a:solidFill>
                 <a:latin typeface="Calibri"/>
               </a:rPr>
-              <a:t>Weighted by Hyde Park's loaded layers the net is 1.17x, beside the two-index model (1.19x). Transformers (1.89x) and switchgear (1.83x) are the fastest risers, so a station-heavy project escalates faster than a battery-heavy one.</a:t>
+              <a:t>Weighted by Hyde Park's loaded layers the net is 1.17x, beside the two-index model (1.19x). Transformers (1.91x) and switchgear (1.82x) are the fastest risers, so a station-heavy project escalates faster than a battery-heavy one.</a:t>
             </a:r>
           </a:p>
           <a:p>
@@ -22205,7 +22241,7 @@
                           </a:solidFill>
                           <a:latin typeface="Calibri"/>
                         </a:rPr>
-                        <a:t>$996</a:t>
+                        <a:t>$994</a:t>
                       </a:r>
                     </a:p>
                   </a:txBody>
@@ -22343,7 +22379,7 @@
                           </a:solidFill>
                           <a:latin typeface="Calibri"/>
                         </a:rPr>
-                        <a:t>84%</a:t>
+                        <a:t>85%</a:t>
                       </a:r>
                     </a:p>
                   </a:txBody>
@@ -22366,7 +22402,7 @@
                           </a:solidFill>
                           <a:latin typeface="Calibri"/>
                         </a:rPr>
-                        <a:t>$1,057</a:t>
+                        <a:t>$1,055</a:t>
                       </a:r>
                     </a:p>
                   </a:txBody>
@@ -22389,7 +22425,7 @@
                           </a:solidFill>
                           <a:latin typeface="Calibri"/>
                         </a:rPr>
-                        <a:t>71%</a:t>
+                        <a:t>74%</a:t>
                       </a:r>
                     </a:p>
                   </a:txBody>
@@ -22458,7 +22494,7 @@
                           </a:solidFill>
                           <a:latin typeface="Calibri"/>
                         </a:rPr>
-                        <a:t>$830</a:t>
+                        <a:t>$829</a:t>
                       </a:r>
                     </a:p>
                   </a:txBody>
@@ -22481,7 +22517,7 @@
                           </a:solidFill>
                           <a:latin typeface="Calibri"/>
                         </a:rPr>
-                        <a:t>56%</a:t>
+                        <a:t>55%</a:t>
                       </a:r>
                     </a:p>
                   </a:txBody>
@@ -22527,7 +22563,7 @@
                           </a:solidFill>
                           <a:latin typeface="Calibri"/>
                         </a:rPr>
-                        <a:t>$1,036</a:t>
+                        <a:t>$1,034</a:t>
                       </a:r>
                     </a:p>
                   </a:txBody>
@@ -22619,7 +22655,7 @@
                           </a:solidFill>
                           <a:latin typeface="Calibri"/>
                         </a:rPr>
-                        <a:t>$779</a:t>
+                        <a:t>$778</a:t>
                       </a:r>
                     </a:p>
                   </a:txBody>
@@ -22688,7 +22724,7 @@
                           </a:solidFill>
                           <a:latin typeface="Calibri"/>
                         </a:rPr>
-                        <a:t>$987</a:t>
+                        <a:t>$986</a:t>
                       </a:r>
                     </a:p>
                   </a:txBody>
@@ -23038,7 +23074,7 @@
                 </a:solidFill>
                 <a:latin typeface="Calibri"/>
               </a:rPr>
-              <a:t>installed 51% to 51% percentile, station 84% to 85%, under every defensible method.</a:t>
+              <a:t>installed 51% to 51% percentile, station 85% to 85%, under every defensible method.</a:t>
             </a:r>
           </a:p>
         </p:txBody>
@@ -30343,7 +30379,7 @@
                 </a:solidFill>
                 <a:latin typeface="Georgia"/>
               </a:rPr>
-              <a:t>Fourteen levers in three tiers: $5.0 to 7.1M in the estimate, $4.3 to 7.0M in scope decisions, and a tax credit larger than both</a:t>
+              <a:t>Fourteen levers in three tiers: $5.0 to 7.1M in the estimate, $4.3 to 6.9M in scope decisions, and a tax credit larger than both</a:t>
             </a:r>
           </a:p>
         </p:txBody>
@@ -32119,7 +32155,7 @@
                           </a:solidFill>
                           <a:latin typeface="Calibri"/>
                         </a:rPr>
-                        <a:t>$0.3 to 0.6M</a:t>
+                        <a:t>$0.3 to 0.5M</a:t>
                       </a:r>
                     </a:p>
                   </a:txBody>
@@ -32142,7 +32178,7 @@
                           </a:solidFill>
                           <a:latin typeface="Calibri"/>
                         </a:rPr>
-                        <a:t>$0.4 to 0.9M</a:t>
+                        <a:t>$0.4 to 0.8M</a:t>
                       </a:r>
                     </a:p>
                   </a:txBody>
@@ -33320,7 +33356,7 @@
                           </a:solidFill>
                           <a:latin typeface="Calibri"/>
                         </a:rPr>
-                        <a:t>$4.3 to 7.0M</a:t>
+                        <a:t>$4.3 to 6.9M</a:t>
                       </a:r>
                     </a:p>
                   </a:txBody>
@@ -33389,7 +33425,7 @@
                           </a:solidFill>
                           <a:latin typeface="Calibri"/>
                         </a:rPr>
-                        <a:t>$9.3 to 14.1M</a:t>
+                        <a:t>$9.3 to 14.0M</a:t>
                       </a:r>
                     </a:p>
                   </a:txBody>
@@ -33619,7 +33655,7 @@
                 </a:solidFill>
                 <a:latin typeface="Calibri"/>
               </a:rPr>
-              <a:t>Tiers A and B ($9.3 to 14.1M) and the Haugland gap (+$4 to 8M) are the same order of magnitude. The honest planning case is a $57M number that holds, not one that falls.</a:t>
+              <a:t>Tiers A and B ($9.3 to 14.0M) and the Haugland gap (+$4 to 8M) are the same order of magnitude. The honest planning case is a $57M number that holds, not one that falls.</a:t>
             </a:r>
           </a:p>
           <a:p>

</xml_diff>

<commit_message>
Final deck: fix the slide 15 and 36 eyebrows, the savings-register table overlap, the containment target text and the deck date
- Slides 15 and 36: eyebrows shortened to one line so they no longer run into the title.
- Slide 27: savings-register table set at 7 pt with rebalanced columns; the footnote no longer overlaps rows C1 and C2.
- Contributions slide and slide 33 notes: the station-direct design-to-cost target now reads from scope_challenge.json ($1,250/kWh) instead of a stale $1,200 literal.
- Title slide dated 5 Oct 2026.

Full 41-slide render checked for overflow; pptx validator passes.

Co-Authored-By: Claude Fable 5.1 <noreply@anthropic.com>
Claude-Session: https://claude.ai/code/session_01YAU7MDk5K6GEm6c4td5TUq
</commit_message>
<xml_diff>
--- a/Hyde Park BESS/6) Cost Analysis Deliverables/Hyde Park BESS - Cost Analysis Deck.pptx
+++ b/Hyde Park BESS/6) Cost Analysis Deliverables/Hyde Park BESS - Cost Analysis Deck.pptx
@@ -8986,7 +8986,7 @@
           <a:lstStyle/>
           <a:p>
             <a:r>
-              <a:t>Design-to-cost: the target is set at a defensible external reference (the reference-class 75th percentile for station-direct cost, about $1,200 per kWh) rather than at an arbitrary cut, so the project can explain to a regulator why it stopped where it stopped. The gates are tied to the documents the red team and the estimating review already said were missing: geotech, NFPA 855 analysis, hosting capacity, GSU count, the Haugland scope map. Competitive lump-sum pricing converts the unit-library construction estimate into a bid, which is the only way to retire the +25% construction stress test.</a:t>
+              <a:t>Design-to-cost: the target is set at a defensible external reference (the reference-class 75th percentile for station-direct cost, about $1,250 per kWh) rather than at an arbitrary cut, so the project can explain to a regulator why it stopped where it stopped. The gates are tied to the documents the red team and the estimating review already said were missing: geotech, NFPA 855 analysis, hosting capacity, GSU count, the Haugland scope map. Competitive lump-sum pricing converts the unit-library construction estimate into a bid, which is the only way to retire the +25% construction stress test.</a:t>
             </a:r>
           </a:p>
         </p:txBody>
@@ -12927,7 +12927,7 @@
                 </a:solidFill>
                 <a:latin typeface="Calibri"/>
               </a:rPr>
-              <a:t>Cost Estimating Center of Excellence  |  Estimate basis: ESF Total Rev 3, 24 Sep 2026  |  29 Sep 2026</a:t>
+              <a:t>Cost Estimating Center of Excellence  |  Estimate basis: ESF Total Rev 3, 24 Sep 2026  |  5 Oct 2026</a:t>
             </a:r>
           </a:p>
         </p:txBody>
@@ -17858,7 +17858,7 @@
                 </a:solidFill>
                 <a:latin typeface="Calibri"/>
               </a:rPr>
-              <a:t>1 · WHERE THE MONEY SITS   |   NORMALIZING TO 2026: SIX INDICES X THREE ANCHOR BATTERY SHARES (2024 BASIS), CLASS MEDIAN $/KWH</a:t>
+              <a:t>1 · WHERE THE MONEY SITS   |   NORMALIZING TO 2026: SIX INDICES X THREE ANCHOR BATTERY SHARES, CLASS MEDIAN $/KWH</a:t>
             </a:r>
           </a:p>
         </p:txBody>
@@ -31484,8 +31484,8 @@
           <p:nvPr/>
         </p:nvGraphicFramePr>
         <p:xfrm>
-          <a:off x="548640" y="1325880"/>
-          <a:ext cx="11064239" cy="4572000"/>
+          <a:off x="548640" y="1280160"/>
+          <a:ext cx="11064240" cy="4572000"/>
         </p:xfrm>
         <a:graphic>
           <a:graphicData uri="http://schemas.openxmlformats.org/drawingml/2006/table">
@@ -31494,13 +31494,13 @@
                 <a:tableStyleId>{5C22544A-7EE6-4342-B048-85BDC9FD1C3A}</a:tableStyleId>
               </a:tblPr>
               <a:tblGrid>
-                <a:gridCol w="365760"/>
-                <a:gridCol w="3749039"/>
-                <a:gridCol w="640080"/>
-                <a:gridCol w="1097280"/>
-                <a:gridCol w="1097280"/>
-                <a:gridCol w="640080"/>
-                <a:gridCol w="3474720"/>
+                <a:gridCol w="320040"/>
+                <a:gridCol w="3931920"/>
+                <a:gridCol w="502920"/>
+                <a:gridCol w="960120"/>
+                <a:gridCol w="1005840"/>
+                <a:gridCol w="548640"/>
+                <a:gridCol w="3794760"/>
               </a:tblGrid>
               <a:tr h="268941">
                 <a:tc>
@@ -31509,7 +31509,7 @@
                     <a:lstStyle/>
                     <a:p>
                       <a:r>
-                        <a:rPr sz="800" b="1">
+                        <a:rPr sz="700" b="1">
                           <a:solidFill>
                             <a:srgbClr val="FFFFFF"/>
                           </a:solidFill>
@@ -31531,7 +31531,7 @@
                     <a:lstStyle/>
                     <a:p>
                       <a:r>
-                        <a:rPr sz="800" b="1">
+                        <a:rPr sz="700" b="1">
                           <a:solidFill>
                             <a:srgbClr val="FFFFFF"/>
                           </a:solidFill>
@@ -31553,7 +31553,7 @@
                     <a:lstStyle/>
                     <a:p>
                       <a:r>
-                        <a:rPr sz="800" b="1">
+                        <a:rPr sz="700" b="1">
                           <a:solidFill>
                             <a:srgbClr val="FFFFFF"/>
                           </a:solidFill>
@@ -31576,7 +31576,7 @@
                     <a:p>
                       <a:pPr algn="r"/>
                       <a:r>
-                        <a:rPr sz="800" b="1">
+                        <a:rPr sz="700" b="1">
                           <a:solidFill>
                             <a:srgbClr val="FFFFFF"/>
                           </a:solidFill>
@@ -31599,7 +31599,7 @@
                     <a:p>
                       <a:pPr algn="r"/>
                       <a:r>
-                        <a:rPr sz="800" b="1">
+                        <a:rPr sz="700" b="1">
                           <a:solidFill>
                             <a:srgbClr val="FFFFFF"/>
                           </a:solidFill>
@@ -31621,7 +31621,7 @@
                     <a:lstStyle/>
                     <a:p>
                       <a:r>
-                        <a:rPr sz="800" b="1">
+                        <a:rPr sz="700" b="1">
                           <a:solidFill>
                             <a:srgbClr val="FFFFFF"/>
                           </a:solidFill>
@@ -31643,7 +31643,7 @@
                     <a:lstStyle/>
                     <a:p>
                       <a:r>
-                        <a:rPr sz="800" b="1">
+                        <a:rPr sz="700" b="1">
                           <a:solidFill>
                             <a:srgbClr val="FFFFFF"/>
                           </a:solidFill>
@@ -31667,7 +31667,7 @@
                     <a:lstStyle/>
                     <a:p>
                       <a:r>
-                        <a:rPr sz="800" b="1">
+                        <a:rPr sz="700" b="1">
                           <a:solidFill>
                             <a:srgbClr val="FFFFFF"/>
                           </a:solidFill>
@@ -31689,7 +31689,7 @@
                     <a:lstStyle/>
                     <a:p>
                       <a:r>
-                        <a:rPr sz="800" b="0">
+                        <a:rPr sz="700" b="0">
                           <a:solidFill>
                             <a:srgbClr val="1F2A44"/>
                           </a:solidFill>
@@ -31711,7 +31711,7 @@
                     <a:lstStyle/>
                     <a:p>
                       <a:r>
-                        <a:rPr sz="800" b="0">
+                        <a:rPr sz="700" b="0">
                           <a:solidFill>
                             <a:srgbClr val="1F2A44"/>
                           </a:solidFill>
@@ -31734,7 +31734,7 @@
                     <a:p>
                       <a:pPr algn="r"/>
                       <a:r>
-                        <a:rPr sz="800" b="0">
+                        <a:rPr sz="700" b="0">
                           <a:solidFill>
                             <a:srgbClr val="1F2A44"/>
                           </a:solidFill>
@@ -31757,7 +31757,7 @@
                     <a:p>
                       <a:pPr algn="r"/>
                       <a:r>
-                        <a:rPr sz="800" b="0">
+                        <a:rPr sz="700" b="0">
                           <a:solidFill>
                             <a:srgbClr val="1F2A44"/>
                           </a:solidFill>
@@ -31779,7 +31779,7 @@
                     <a:lstStyle/>
                     <a:p>
                       <a:r>
-                        <a:rPr sz="800" b="0">
+                        <a:rPr sz="700" b="0">
                           <a:solidFill>
                             <a:srgbClr val="1F2A44"/>
                           </a:solidFill>
@@ -31801,7 +31801,7 @@
                     <a:lstStyle/>
                     <a:p>
                       <a:r>
-                        <a:rPr sz="800" b="0">
+                        <a:rPr sz="700" b="0">
                           <a:solidFill>
                             <a:srgbClr val="1F2A44"/>
                           </a:solidFill>
@@ -31825,7 +31825,7 @@
                     <a:lstStyle/>
                     <a:p>
                       <a:r>
-                        <a:rPr sz="800" b="1">
+                        <a:rPr sz="700" b="1">
                           <a:solidFill>
                             <a:srgbClr val="FFFFFF"/>
                           </a:solidFill>
@@ -31847,7 +31847,7 @@
                     <a:lstStyle/>
                     <a:p>
                       <a:r>
-                        <a:rPr sz="800" b="0">
+                        <a:rPr sz="700" b="0">
                           <a:solidFill>
                             <a:srgbClr val="1F2A44"/>
                           </a:solidFill>
@@ -31869,7 +31869,7 @@
                     <a:lstStyle/>
                     <a:p>
                       <a:r>
-                        <a:rPr sz="800" b="0">
+                        <a:rPr sz="700" b="0">
                           <a:solidFill>
                             <a:srgbClr val="1F2A44"/>
                           </a:solidFill>
@@ -31892,7 +31892,7 @@
                     <a:p>
                       <a:pPr algn="r"/>
                       <a:r>
-                        <a:rPr sz="800" b="0">
+                        <a:rPr sz="700" b="0">
                           <a:solidFill>
                             <a:srgbClr val="1F2A44"/>
                           </a:solidFill>
@@ -31915,7 +31915,7 @@
                     <a:p>
                       <a:pPr algn="r"/>
                       <a:r>
-                        <a:rPr sz="800" b="0">
+                        <a:rPr sz="700" b="0">
                           <a:solidFill>
                             <a:srgbClr val="1F2A44"/>
                           </a:solidFill>
@@ -31937,7 +31937,7 @@
                     <a:lstStyle/>
                     <a:p>
                       <a:r>
-                        <a:rPr sz="800" b="0">
+                        <a:rPr sz="700" b="0">
                           <a:solidFill>
                             <a:srgbClr val="1F2A44"/>
                           </a:solidFill>
@@ -31959,7 +31959,7 @@
                     <a:lstStyle/>
                     <a:p>
                       <a:r>
-                        <a:rPr sz="800" b="0">
+                        <a:rPr sz="700" b="0">
                           <a:solidFill>
                             <a:srgbClr val="1F2A44"/>
                           </a:solidFill>
@@ -31983,7 +31983,7 @@
                     <a:lstStyle/>
                     <a:p>
                       <a:r>
-                        <a:rPr sz="800" b="1">
+                        <a:rPr sz="700" b="1">
                           <a:solidFill>
                             <a:srgbClr val="FFFFFF"/>
                           </a:solidFill>
@@ -32005,7 +32005,7 @@
                     <a:lstStyle/>
                     <a:p>
                       <a:r>
-                        <a:rPr sz="800" b="0">
+                        <a:rPr sz="700" b="0">
                           <a:solidFill>
                             <a:srgbClr val="1F2A44"/>
                           </a:solidFill>
@@ -32027,7 +32027,7 @@
                     <a:lstStyle/>
                     <a:p>
                       <a:r>
-                        <a:rPr sz="800" b="0">
+                        <a:rPr sz="700" b="0">
                           <a:solidFill>
                             <a:srgbClr val="1F2A44"/>
                           </a:solidFill>
@@ -32050,7 +32050,7 @@
                     <a:p>
                       <a:pPr algn="r"/>
                       <a:r>
-                        <a:rPr sz="800" b="0">
+                        <a:rPr sz="700" b="0">
                           <a:solidFill>
                             <a:srgbClr val="1F2A44"/>
                           </a:solidFill>
@@ -32073,7 +32073,7 @@
                     <a:p>
                       <a:pPr algn="r"/>
                       <a:r>
-                        <a:rPr sz="800" b="0">
+                        <a:rPr sz="700" b="0">
                           <a:solidFill>
                             <a:srgbClr val="1F2A44"/>
                           </a:solidFill>
@@ -32095,7 +32095,7 @@
                     <a:lstStyle/>
                     <a:p>
                       <a:r>
-                        <a:rPr sz="800" b="0">
+                        <a:rPr sz="700" b="0">
                           <a:solidFill>
                             <a:srgbClr val="1F2A44"/>
                           </a:solidFill>
@@ -32117,7 +32117,7 @@
                     <a:lstStyle/>
                     <a:p>
                       <a:r>
-                        <a:rPr sz="800" b="0">
+                        <a:rPr sz="700" b="0">
                           <a:solidFill>
                             <a:srgbClr val="1F2A44"/>
                           </a:solidFill>
@@ -32141,7 +32141,7 @@
                     <a:lstStyle/>
                     <a:p>
                       <a:r>
-                        <a:rPr sz="800" b="1">
+                        <a:rPr sz="700" b="1">
                           <a:solidFill>
                             <a:srgbClr val="FFFFFF"/>
                           </a:solidFill>
@@ -32163,7 +32163,7 @@
                     <a:lstStyle/>
                     <a:p>
                       <a:r>
-                        <a:rPr sz="800" b="0">
+                        <a:rPr sz="700" b="0">
                           <a:solidFill>
                             <a:srgbClr val="1F2A44"/>
                           </a:solidFill>
@@ -32185,7 +32185,7 @@
                     <a:lstStyle/>
                     <a:p>
                       <a:r>
-                        <a:rPr sz="800" b="0">
+                        <a:rPr sz="700" b="0">
                           <a:solidFill>
                             <a:srgbClr val="1F2A44"/>
                           </a:solidFill>
@@ -32208,7 +32208,7 @@
                     <a:p>
                       <a:pPr algn="r"/>
                       <a:r>
-                        <a:rPr sz="800" b="0">
+                        <a:rPr sz="700" b="0">
                           <a:solidFill>
                             <a:srgbClr val="1F2A44"/>
                           </a:solidFill>
@@ -32231,7 +32231,7 @@
                     <a:p>
                       <a:pPr algn="r"/>
                       <a:r>
-                        <a:rPr sz="800" b="0">
+                        <a:rPr sz="700" b="0">
                           <a:solidFill>
                             <a:srgbClr val="1F2A44"/>
                           </a:solidFill>
@@ -32253,7 +32253,7 @@
                     <a:lstStyle/>
                     <a:p>
                       <a:r>
-                        <a:rPr sz="800" b="0">
+                        <a:rPr sz="700" b="0">
                           <a:solidFill>
                             <a:srgbClr val="1F2A44"/>
                           </a:solidFill>
@@ -32275,7 +32275,7 @@
                     <a:lstStyle/>
                     <a:p>
                       <a:r>
-                        <a:rPr sz="800" b="0">
+                        <a:rPr sz="700" b="0">
                           <a:solidFill>
                             <a:srgbClr val="1F2A44"/>
                           </a:solidFill>
@@ -32299,7 +32299,7 @@
                     <a:lstStyle/>
                     <a:p>
                       <a:r>
-                        <a:rPr sz="800" b="1">
+                        <a:rPr sz="700" b="1">
                           <a:solidFill>
                             <a:srgbClr val="FFFFFF"/>
                           </a:solidFill>
@@ -32321,7 +32321,7 @@
                     <a:lstStyle/>
                     <a:p>
                       <a:r>
-                        <a:rPr sz="800" b="0">
+                        <a:rPr sz="700" b="0">
                           <a:solidFill>
                             <a:srgbClr val="1F2A44"/>
                           </a:solidFill>
@@ -32343,7 +32343,7 @@
                     <a:lstStyle/>
                     <a:p>
                       <a:r>
-                        <a:rPr sz="800" b="0">
+                        <a:rPr sz="700" b="0">
                           <a:solidFill>
                             <a:srgbClr val="1F2A44"/>
                           </a:solidFill>
@@ -32366,7 +32366,7 @@
                     <a:p>
                       <a:pPr algn="r"/>
                       <a:r>
-                        <a:rPr sz="800" b="0">
+                        <a:rPr sz="700" b="0">
                           <a:solidFill>
                             <a:srgbClr val="1F2A44"/>
                           </a:solidFill>
@@ -32389,7 +32389,7 @@
                     <a:p>
                       <a:pPr algn="r"/>
                       <a:r>
-                        <a:rPr sz="800" b="0">
+                        <a:rPr sz="700" b="0">
                           <a:solidFill>
                             <a:srgbClr val="1F2A44"/>
                           </a:solidFill>
@@ -32411,7 +32411,7 @@
                     <a:lstStyle/>
                     <a:p>
                       <a:r>
-                        <a:rPr sz="800" b="0">
+                        <a:rPr sz="700" b="0">
                           <a:solidFill>
                             <a:srgbClr val="1F2A44"/>
                           </a:solidFill>
@@ -32433,7 +32433,7 @@
                     <a:lstStyle/>
                     <a:p>
                       <a:r>
-                        <a:rPr sz="800" b="0">
+                        <a:rPr sz="700" b="0">
                           <a:solidFill>
                             <a:srgbClr val="1F2A44"/>
                           </a:solidFill>
@@ -32457,7 +32457,7 @@
                     <a:lstStyle/>
                     <a:p>
                       <a:r>
-                        <a:rPr sz="800" b="1">
+                        <a:rPr sz="700" b="1">
                           <a:solidFill>
                             <a:srgbClr val="FFFFFF"/>
                           </a:solidFill>
@@ -32479,7 +32479,7 @@
                     <a:lstStyle/>
                     <a:p>
                       <a:r>
-                        <a:rPr sz="800" b="0">
+                        <a:rPr sz="700" b="0">
                           <a:solidFill>
                             <a:srgbClr val="1F2A44"/>
                           </a:solidFill>
@@ -32501,7 +32501,7 @@
                     <a:lstStyle/>
                     <a:p>
                       <a:r>
-                        <a:rPr sz="800" b="0">
+                        <a:rPr sz="700" b="0">
                           <a:solidFill>
                             <a:srgbClr val="1F2A44"/>
                           </a:solidFill>
@@ -32524,7 +32524,7 @@
                     <a:p>
                       <a:pPr algn="r"/>
                       <a:r>
-                        <a:rPr sz="800" b="0">
+                        <a:rPr sz="700" b="0">
                           <a:solidFill>
                             <a:srgbClr val="1F2A44"/>
                           </a:solidFill>
@@ -32547,7 +32547,7 @@
                     <a:p>
                       <a:pPr algn="r"/>
                       <a:r>
-                        <a:rPr sz="800" b="0">
+                        <a:rPr sz="700" b="0">
                           <a:solidFill>
                             <a:srgbClr val="1F2A44"/>
                           </a:solidFill>
@@ -32569,7 +32569,7 @@
                     <a:lstStyle/>
                     <a:p>
                       <a:r>
-                        <a:rPr sz="800" b="0">
+                        <a:rPr sz="700" b="0">
                           <a:solidFill>
                             <a:srgbClr val="1F2A44"/>
                           </a:solidFill>
@@ -32591,7 +32591,7 @@
                     <a:lstStyle/>
                     <a:p>
                       <a:r>
-                        <a:rPr sz="800" b="0">
+                        <a:rPr sz="700" b="0">
                           <a:solidFill>
                             <a:srgbClr val="1F2A44"/>
                           </a:solidFill>
@@ -32615,7 +32615,7 @@
                     <a:lstStyle/>
                     <a:p>
                       <a:r>
-                        <a:rPr sz="800" b="1">
+                        <a:rPr sz="700" b="1">
                           <a:solidFill>
                             <a:srgbClr val="FFFFFF"/>
                           </a:solidFill>
@@ -32637,7 +32637,7 @@
                     <a:lstStyle/>
                     <a:p>
                       <a:r>
-                        <a:rPr sz="800" b="0">
+                        <a:rPr sz="700" b="0">
                           <a:solidFill>
                             <a:srgbClr val="1F2A44"/>
                           </a:solidFill>
@@ -32659,7 +32659,7 @@
                     <a:lstStyle/>
                     <a:p>
                       <a:r>
-                        <a:rPr sz="800" b="0">
+                        <a:rPr sz="700" b="0">
                           <a:solidFill>
                             <a:srgbClr val="1F2A44"/>
                           </a:solidFill>
@@ -32682,7 +32682,7 @@
                     <a:p>
                       <a:pPr algn="r"/>
                       <a:r>
-                        <a:rPr sz="800" b="0">
+                        <a:rPr sz="700" b="0">
                           <a:solidFill>
                             <a:srgbClr val="1F2A44"/>
                           </a:solidFill>
@@ -32705,7 +32705,7 @@
                     <a:p>
                       <a:pPr algn="r"/>
                       <a:r>
-                        <a:rPr sz="800" b="0">
+                        <a:rPr sz="700" b="0">
                           <a:solidFill>
                             <a:srgbClr val="1F2A44"/>
                           </a:solidFill>
@@ -32727,7 +32727,7 @@
                     <a:lstStyle/>
                     <a:p>
                       <a:r>
-                        <a:rPr sz="800" b="0">
+                        <a:rPr sz="700" b="0">
                           <a:solidFill>
                             <a:srgbClr val="1F2A44"/>
                           </a:solidFill>
@@ -32749,7 +32749,7 @@
                     <a:lstStyle/>
                     <a:p>
                       <a:r>
-                        <a:rPr sz="800" b="0">
+                        <a:rPr sz="700" b="0">
                           <a:solidFill>
                             <a:srgbClr val="1F2A44"/>
                           </a:solidFill>
@@ -32773,7 +32773,7 @@
                     <a:lstStyle/>
                     <a:p>
                       <a:r>
-                        <a:rPr sz="800" b="1">
+                        <a:rPr sz="700" b="1">
                           <a:solidFill>
                             <a:srgbClr val="FFFFFF"/>
                           </a:solidFill>
@@ -32795,7 +32795,7 @@
                     <a:lstStyle/>
                     <a:p>
                       <a:r>
-                        <a:rPr sz="800" b="0">
+                        <a:rPr sz="700" b="0">
                           <a:solidFill>
                             <a:srgbClr val="1F2A44"/>
                           </a:solidFill>
@@ -32817,7 +32817,7 @@
                     <a:lstStyle/>
                     <a:p>
                       <a:r>
-                        <a:rPr sz="800" b="0">
+                        <a:rPr sz="700" b="0">
                           <a:solidFill>
                             <a:srgbClr val="1F2A44"/>
                           </a:solidFill>
@@ -32840,7 +32840,7 @@
                     <a:p>
                       <a:pPr algn="r"/>
                       <a:r>
-                        <a:rPr sz="800" b="0">
+                        <a:rPr sz="700" b="0">
                           <a:solidFill>
                             <a:srgbClr val="1F2A44"/>
                           </a:solidFill>
@@ -32863,7 +32863,7 @@
                     <a:p>
                       <a:pPr algn="r"/>
                       <a:r>
-                        <a:rPr sz="800" b="0">
+                        <a:rPr sz="700" b="0">
                           <a:solidFill>
                             <a:srgbClr val="1F2A44"/>
                           </a:solidFill>
@@ -32885,7 +32885,7 @@
                     <a:lstStyle/>
                     <a:p>
                       <a:r>
-                        <a:rPr sz="800" b="0">
+                        <a:rPr sz="700" b="0">
                           <a:solidFill>
                             <a:srgbClr val="1F2A44"/>
                           </a:solidFill>
@@ -32907,7 +32907,7 @@
                     <a:lstStyle/>
                     <a:p>
                       <a:r>
-                        <a:rPr sz="800" b="0">
+                        <a:rPr sz="700" b="0">
                           <a:solidFill>
                             <a:srgbClr val="1F2A44"/>
                           </a:solidFill>
@@ -32931,7 +32931,7 @@
                     <a:lstStyle/>
                     <a:p>
                       <a:r>
-                        <a:rPr sz="800" b="1">
+                        <a:rPr sz="700" b="1">
                           <a:solidFill>
                             <a:srgbClr val="FFFFFF"/>
                           </a:solidFill>
@@ -32953,7 +32953,7 @@
                     <a:lstStyle/>
                     <a:p>
                       <a:r>
-                        <a:rPr sz="800" b="0">
+                        <a:rPr sz="700" b="0">
                           <a:solidFill>
                             <a:srgbClr val="1F2A44"/>
                           </a:solidFill>
@@ -32975,7 +32975,7 @@
                     <a:lstStyle/>
                     <a:p>
                       <a:r>
-                        <a:rPr sz="800" b="0">
+                        <a:rPr sz="700" b="0">
                           <a:solidFill>
                             <a:srgbClr val="1F2A44"/>
                           </a:solidFill>
@@ -32998,7 +32998,7 @@
                     <a:p>
                       <a:pPr algn="r"/>
                       <a:r>
-                        <a:rPr sz="800" b="0">
+                        <a:rPr sz="700" b="0">
                           <a:solidFill>
                             <a:srgbClr val="1F2A44"/>
                           </a:solidFill>
@@ -33021,7 +33021,7 @@
                     <a:p>
                       <a:pPr algn="r"/>
                       <a:r>
-                        <a:rPr sz="800" b="0">
+                        <a:rPr sz="700" b="0">
                           <a:solidFill>
                             <a:srgbClr val="1F2A44"/>
                           </a:solidFill>
@@ -33043,7 +33043,7 @@
                     <a:lstStyle/>
                     <a:p>
                       <a:r>
-                        <a:rPr sz="800" b="0">
+                        <a:rPr sz="700" b="0">
                           <a:solidFill>
                             <a:srgbClr val="1F2A44"/>
                           </a:solidFill>
@@ -33065,7 +33065,7 @@
                     <a:lstStyle/>
                     <a:p>
                       <a:r>
-                        <a:rPr sz="800" b="0">
+                        <a:rPr sz="700" b="0">
                           <a:solidFill>
                             <a:srgbClr val="1F2A44"/>
                           </a:solidFill>
@@ -33089,7 +33089,7 @@
                     <a:lstStyle/>
                     <a:p>
                       <a:r>
-                        <a:rPr sz="800" b="1">
+                        <a:rPr sz="700" b="1">
                           <a:solidFill>
                             <a:srgbClr val="FFFFFF"/>
                           </a:solidFill>
@@ -33111,7 +33111,7 @@
                     <a:lstStyle/>
                     <a:p>
                       <a:r>
-                        <a:rPr sz="800" b="0">
+                        <a:rPr sz="700" b="0">
                           <a:solidFill>
                             <a:srgbClr val="1F2A44"/>
                           </a:solidFill>
@@ -33133,7 +33133,7 @@
                     <a:lstStyle/>
                     <a:p>
                       <a:r>
-                        <a:rPr sz="800" b="0">
+                        <a:rPr sz="700" b="0">
                           <a:solidFill>
                             <a:srgbClr val="1F2A44"/>
                           </a:solidFill>
@@ -33156,7 +33156,7 @@
                     <a:p>
                       <a:pPr algn="r"/>
                       <a:r>
-                        <a:rPr sz="800" b="0">
+                        <a:rPr sz="700" b="0">
                           <a:solidFill>
                             <a:srgbClr val="1F2A44"/>
                           </a:solidFill>
@@ -33179,7 +33179,7 @@
                     <a:p>
                       <a:pPr algn="r"/>
                       <a:r>
-                        <a:rPr sz="800" b="0">
+                        <a:rPr sz="700" b="0">
                           <a:solidFill>
                             <a:srgbClr val="1F2A44"/>
                           </a:solidFill>
@@ -33201,7 +33201,7 @@
                     <a:lstStyle/>
                     <a:p>
                       <a:r>
-                        <a:rPr sz="800" b="0">
+                        <a:rPr sz="700" b="0">
                           <a:solidFill>
                             <a:srgbClr val="1F2A44"/>
                           </a:solidFill>
@@ -33223,7 +33223,7 @@
                     <a:lstStyle/>
                     <a:p>
                       <a:r>
-                        <a:rPr sz="800" b="0">
+                        <a:rPr sz="700" b="0">
                           <a:solidFill>
                             <a:srgbClr val="1F2A44"/>
                           </a:solidFill>
@@ -33247,7 +33247,7 @@
                     <a:lstStyle/>
                     <a:p>
                       <a:r>
-                        <a:rPr sz="800" b="1">
+                        <a:rPr sz="700" b="1">
                           <a:solidFill>
                             <a:srgbClr val="FFFFFF"/>
                           </a:solidFill>
@@ -33269,7 +33269,7 @@
                     <a:lstStyle/>
                     <a:p>
                       <a:r>
-                        <a:rPr sz="800" b="0">
+                        <a:rPr sz="700" b="0">
                           <a:solidFill>
                             <a:srgbClr val="1F2A44"/>
                           </a:solidFill>
@@ -33291,7 +33291,7 @@
                     <a:lstStyle/>
                     <a:p>
                       <a:r>
-                        <a:rPr sz="800" b="0">
+                        <a:rPr sz="700" b="0">
                           <a:solidFill>
                             <a:srgbClr val="1F2A44"/>
                           </a:solidFill>
@@ -33314,7 +33314,7 @@
                     <a:p>
                       <a:pPr algn="r"/>
                       <a:r>
-                        <a:rPr sz="800" b="0">
+                        <a:rPr sz="700" b="0">
                           <a:solidFill>
                             <a:srgbClr val="1F2A44"/>
                           </a:solidFill>
@@ -33337,7 +33337,7 @@
                     <a:p>
                       <a:pPr algn="r"/>
                       <a:r>
-                        <a:rPr sz="800" b="0">
+                        <a:rPr sz="700" b="0">
                           <a:solidFill>
                             <a:srgbClr val="1F2A44"/>
                           </a:solidFill>
@@ -33359,7 +33359,7 @@
                     <a:lstStyle/>
                     <a:p>
                       <a:r>
-                        <a:rPr sz="800" b="0">
+                        <a:rPr sz="700" b="0">
                           <a:solidFill>
                             <a:srgbClr val="1F2A44"/>
                           </a:solidFill>
@@ -33381,7 +33381,7 @@
                     <a:lstStyle/>
                     <a:p>
                       <a:r>
-                        <a:rPr sz="800" b="0">
+                        <a:rPr sz="700" b="0">
                           <a:solidFill>
                             <a:srgbClr val="1F2A44"/>
                           </a:solidFill>
@@ -33405,7 +33405,7 @@
                     <a:lstStyle/>
                     <a:p>
                       <a:r>
-                        <a:rPr sz="800" b="1">
+                        <a:rPr sz="700" b="1">
                           <a:solidFill>
                             <a:srgbClr val="FFFFFF"/>
                           </a:solidFill>
@@ -33427,7 +33427,7 @@
                     <a:lstStyle/>
                     <a:p>
                       <a:r>
-                        <a:rPr sz="800" b="0">
+                        <a:rPr sz="700" b="0">
                           <a:solidFill>
                             <a:srgbClr val="1F2A44"/>
                           </a:solidFill>
@@ -33449,7 +33449,7 @@
                     <a:lstStyle/>
                     <a:p>
                       <a:r>
-                        <a:rPr sz="800" b="0">
+                        <a:rPr sz="700" b="0">
                           <a:solidFill>
                             <a:srgbClr val="1F2A44"/>
                           </a:solidFill>
@@ -33472,7 +33472,7 @@
                     <a:p>
                       <a:pPr algn="r"/>
                       <a:r>
-                        <a:rPr sz="800" b="0">
+                        <a:rPr sz="700" b="0">
                           <a:solidFill>
                             <a:srgbClr val="1F2A44"/>
                           </a:solidFill>
@@ -33495,7 +33495,7 @@
                     <a:p>
                       <a:pPr algn="r"/>
                       <a:r>
-                        <a:rPr sz="800" b="0">
+                        <a:rPr sz="700" b="0">
                           <a:solidFill>
                             <a:srgbClr val="1F2A44"/>
                           </a:solidFill>
@@ -33517,7 +33517,7 @@
                     <a:lstStyle/>
                     <a:p>
                       <a:r>
-                        <a:rPr sz="800" b="0">
+                        <a:rPr sz="700" b="0">
                           <a:solidFill>
                             <a:srgbClr val="1F2A44"/>
                           </a:solidFill>
@@ -33539,7 +33539,7 @@
                     <a:lstStyle/>
                     <a:p>
                       <a:r>
-                        <a:rPr sz="800" b="0">
+                        <a:rPr sz="700" b="0">
                           <a:solidFill>
                             <a:srgbClr val="1F2A44"/>
                           </a:solidFill>
@@ -33563,7 +33563,7 @@
                     <a:lstStyle/>
                     <a:p>
                       <a:r>
-                        <a:rPr sz="800" b="1">
+                        <a:rPr sz="700" b="1">
                           <a:solidFill>
                             <a:srgbClr val="FFFFFF"/>
                           </a:solidFill>
@@ -33585,7 +33585,7 @@
                     <a:lstStyle/>
                     <a:p>
                       <a:r>
-                        <a:rPr sz="800" b="0">
+                        <a:rPr sz="700" b="0">
                           <a:solidFill>
                             <a:srgbClr val="1F2A44"/>
                           </a:solidFill>
@@ -33607,7 +33607,7 @@
                     <a:lstStyle/>
                     <a:p>
                       <a:r>
-                        <a:rPr sz="800" b="0">
+                        <a:rPr sz="700" b="0">
                           <a:solidFill>
                             <a:srgbClr val="1F2A44"/>
                           </a:solidFill>
@@ -33630,7 +33630,7 @@
                     <a:p>
                       <a:pPr algn="r"/>
                       <a:r>
-                        <a:rPr sz="800" b="0">
+                        <a:rPr sz="700" b="0">
                           <a:solidFill>
                             <a:srgbClr val="1F2A44"/>
                           </a:solidFill>
@@ -33653,7 +33653,7 @@
                     <a:p>
                       <a:pPr algn="r"/>
                       <a:r>
-                        <a:rPr sz="800" b="0">
+                        <a:rPr sz="700" b="0">
                           <a:solidFill>
                             <a:srgbClr val="1F2A44"/>
                           </a:solidFill>
@@ -33675,7 +33675,7 @@
                     <a:lstStyle/>
                     <a:p>
                       <a:r>
-                        <a:rPr sz="800" b="0">
+                        <a:rPr sz="700" b="0">
                           <a:solidFill>
                             <a:srgbClr val="1F2A44"/>
                           </a:solidFill>
@@ -33697,7 +33697,7 @@
                     <a:lstStyle/>
                     <a:p>
                       <a:r>
-                        <a:rPr sz="800" b="0">
+                        <a:rPr sz="700" b="0">
                           <a:solidFill>
                             <a:srgbClr val="1F2A44"/>
                           </a:solidFill>
@@ -33721,7 +33721,7 @@
                     <a:lstStyle/>
                     <a:p>
                       <a:r>
-                        <a:rPr sz="800" b="1">
+                        <a:rPr sz="700" b="1">
                           <a:solidFill>
                             <a:srgbClr val="FFFFFF"/>
                           </a:solidFill>
@@ -33743,7 +33743,7 @@
                     <a:lstStyle/>
                     <a:p>
                       <a:r>
-                        <a:rPr sz="800" b="0">
+                        <a:rPr sz="700" b="0">
                           <a:solidFill>
                             <a:srgbClr val="1F2A44"/>
                           </a:solidFill>
@@ -33765,7 +33765,7 @@
                     <a:lstStyle/>
                     <a:p>
                       <a:r>
-                        <a:rPr sz="800" b="0">
+                        <a:rPr sz="700" b="0">
                           <a:solidFill>
                             <a:srgbClr val="1F2A44"/>
                           </a:solidFill>
@@ -33788,7 +33788,7 @@
                     <a:p>
                       <a:pPr algn="r"/>
                       <a:r>
-                        <a:rPr sz="800" b="0">
+                        <a:rPr sz="700" b="0">
                           <a:solidFill>
                             <a:srgbClr val="1F2A44"/>
                           </a:solidFill>
@@ -33811,7 +33811,7 @@
                     <a:p>
                       <a:pPr algn="r"/>
                       <a:r>
-                        <a:rPr sz="800" b="0">
+                        <a:rPr sz="700" b="0">
                           <a:solidFill>
                             <a:srgbClr val="1F2A44"/>
                           </a:solidFill>
@@ -33833,7 +33833,7 @@
                     <a:lstStyle/>
                     <a:p>
                       <a:r>
-                        <a:rPr sz="800" b="0">
+                        <a:rPr sz="700" b="0">
                           <a:solidFill>
                             <a:srgbClr val="1F2A44"/>
                           </a:solidFill>
@@ -33855,7 +33855,7 @@
                     <a:lstStyle/>
                     <a:p>
                       <a:r>
-                        <a:rPr sz="800" b="0">
+                        <a:rPr sz="700" b="0">
                           <a:solidFill>
                             <a:srgbClr val="1F2A44"/>
                           </a:solidFill>
@@ -33879,7 +33879,7 @@
                     <a:lstStyle/>
                     <a:p>
                       <a:r>
-                        <a:rPr sz="800" b="1">
+                        <a:rPr sz="700" b="1">
                           <a:solidFill>
                             <a:srgbClr val="FFFFFF"/>
                           </a:solidFill>
@@ -33901,7 +33901,7 @@
                     <a:lstStyle/>
                     <a:p>
                       <a:r>
-                        <a:rPr sz="800" b="0">
+                        <a:rPr sz="700" b="0">
                           <a:solidFill>
                             <a:srgbClr val="1F2A44"/>
                           </a:solidFill>
@@ -33923,7 +33923,7 @@
                     <a:lstStyle/>
                     <a:p>
                       <a:r>
-                        <a:rPr sz="800" b="0">
+                        <a:rPr sz="700" b="0">
                           <a:solidFill>
                             <a:srgbClr val="1F2A44"/>
                           </a:solidFill>
@@ -33946,7 +33946,7 @@
                     <a:p>
                       <a:pPr algn="r"/>
                       <a:r>
-                        <a:rPr sz="800" b="0">
+                        <a:rPr sz="700" b="0">
                           <a:solidFill>
                             <a:srgbClr val="1F2A44"/>
                           </a:solidFill>
@@ -33969,7 +33969,7 @@
                     <a:p>
                       <a:pPr algn="r"/>
                       <a:r>
-                        <a:rPr sz="800" b="0">
+                        <a:rPr sz="700" b="0">
                           <a:solidFill>
                             <a:srgbClr val="1F2A44"/>
                           </a:solidFill>
@@ -33991,7 +33991,7 @@
                     <a:lstStyle/>
                     <a:p>
                       <a:r>
-                        <a:rPr sz="800" b="0">
+                        <a:rPr sz="700" b="0">
                           <a:solidFill>
                             <a:srgbClr val="1F2A44"/>
                           </a:solidFill>
@@ -34013,7 +34013,7 @@
                     <a:lstStyle/>
                     <a:p>
                       <a:r>
-                        <a:rPr sz="800" b="0">
+                        <a:rPr sz="700" b="0">
                           <a:solidFill>
                             <a:srgbClr val="1F2A44"/>
                           </a:solidFill>
@@ -34037,7 +34037,7 @@
                     <a:lstStyle/>
                     <a:p>
                       <a:r>
-                        <a:rPr sz="800" b="1">
+                        <a:rPr sz="700" b="1">
                           <a:solidFill>
                             <a:srgbClr val="FFFFFF"/>
                           </a:solidFill>
@@ -34059,7 +34059,7 @@
                     <a:lstStyle/>
                     <a:p>
                       <a:r>
-                        <a:rPr sz="800" b="0">
+                        <a:rPr sz="700" b="0">
                           <a:solidFill>
                             <a:srgbClr val="1F2A44"/>
                           </a:solidFill>
@@ -34081,7 +34081,7 @@
                     <a:lstStyle/>
                     <a:p>
                       <a:r>
-                        <a:rPr sz="800" b="0">
+                        <a:rPr sz="700" b="0">
                           <a:solidFill>
                             <a:srgbClr val="1F2A44"/>
                           </a:solidFill>
@@ -34104,7 +34104,7 @@
                     <a:p>
                       <a:pPr algn="r"/>
                       <a:r>
-                        <a:rPr sz="800" b="0">
+                        <a:rPr sz="700" b="0">
                           <a:solidFill>
                             <a:srgbClr val="1F2A44"/>
                           </a:solidFill>
@@ -34127,7 +34127,7 @@
                     <a:p>
                       <a:pPr algn="r"/>
                       <a:r>
-                        <a:rPr sz="800" b="0">
+                        <a:rPr sz="700" b="0">
                           <a:solidFill>
                             <a:srgbClr val="1F2A44"/>
                           </a:solidFill>
@@ -34149,7 +34149,7 @@
                     <a:lstStyle/>
                     <a:p>
                       <a:r>
-                        <a:rPr sz="800" b="0">
+                        <a:rPr sz="700" b="0">
                           <a:solidFill>
                             <a:srgbClr val="1F2A44"/>
                           </a:solidFill>
@@ -34171,7 +34171,7 @@
                     <a:lstStyle/>
                     <a:p>
                       <a:r>
-                        <a:rPr sz="800" b="0">
+                        <a:rPr sz="700" b="0">
                           <a:solidFill>
                             <a:srgbClr val="1F2A44"/>
                           </a:solidFill>
@@ -34200,8 +34200,8 @@
         </p:nvSpPr>
         <p:spPr>
           <a:xfrm>
-            <a:off x="548640" y="6016752"/>
-            <a:ext cx="11064240" cy="411480"/>
+            <a:off x="548640" y="6144768"/>
+            <a:ext cx="11064240" cy="365760"/>
           </a:xfrm>
           <a:prstGeom prst="rect">
             <a:avLst/>
@@ -43342,7 +43342,7 @@
                 </a:solidFill>
                 <a:latin typeface="Calibri"/>
               </a:rPr>
-              <a:t>3 · CAN THE NUMBER BE DEFENDED   |   OPPORTUNITIES LEFT, THREATS RIGHT: P10 TO P90 OF EACH DRIVER'S EFFECT ON THE LOADED TOTAL, $M</a:t>
+              <a:t>3 · CAN THE NUMBER BE DEFENDED   |   TORNADO: P10 TO P90 EFFECT OF EACH DRIVER ON THE LOADED TOTAL, $M</a:t>
             </a:r>
           </a:p>
         </p:txBody>
@@ -45519,7 +45519,7 @@
                 </a:solidFill>
                 <a:latin typeface="Calibri"/>
               </a:rPr>
-              <a:t>Adopt the containment plan: a $1,200 per kWh station-direct target at IFC, five gates with owners, competitive lump-sum pricing of the station and civil scope, and a monthly cost-containment report.</a:t>
+              <a:t>Adopt the containment plan: a $1,250 per kWh station-direct target at IFC, five gates with owners, competitive lump-sum pricing of the station and civil scope, and a monthly cost-containment report.</a:t>
             </a:r>
           </a:p>
         </p:txBody>

</xml_diff>